<commit_message>
feat(presentation): match exact SIH template visuals, workflows and diagrams for Drishti-Skilling
</commit_message>
<xml_diff>
--- a/presentation/Drishti_Skilling_SIH2024_Presentation.pptx
+++ b/presentation/Drishti_Skilling_SIH2024_Presentation.pptx
@@ -3328,7 +3328,7 @@
       </p:sp>
       <p:pic>
         <p:nvPicPr>
-          <p:cNvPr id="5" name="Picture 4" descr="slide_1_img_2.png"/>
+          <p:cNvPr id="5" name="Picture 4" descr="sih_bulb_clean.png"/>
           <p:cNvPicPr>
             <a:picLocks noChangeAspect="1"/>
           </p:cNvPicPr>
@@ -3342,8 +3342,8 @@
         </p:blipFill>
         <p:spPr>
           <a:xfrm>
-            <a:off x="6858000" y="1371600"/>
-            <a:ext cx="3474720" cy="1489650"/>
+            <a:off x="7589520" y="1188720"/>
+            <a:ext cx="3017520" cy="3234899"/>
           </a:xfrm>
           <a:prstGeom prst="rect">
             <a:avLst/>
@@ -3358,7 +3358,7 @@
         </p:nvSpPr>
         <p:spPr>
           <a:xfrm>
-            <a:off x="6400800" y="5029200"/>
+            <a:off x="6583680" y="4846320"/>
             <a:ext cx="5029200" cy="1280160"/>
           </a:xfrm>
           <a:prstGeom prst="rect">
@@ -3606,11 +3606,11 @@
           </a:fontRef>
         </p:style>
         <p:txBody>
-          <a:bodyPr rtlCol="0" anchor="ctr" wrap="square" lIns="274320" rIns="274320" tIns="228600"/>
+          <a:bodyPr rtlCol="0" anchor="ctr" wrap="square" lIns="228600" rIns="228600" tIns="182880"/>
           <a:lstStyle/>
           <a:p>
             <a:pPr algn="ctr">
-              <a:defRPr sz="1500" b="1">
+              <a:defRPr sz="1400" b="1">
                 <a:solidFill>
                   <a:srgbClr val="007E8A"/>
                 </a:solidFill>
@@ -3624,9 +3624,9 @@
           <a:p>
             <a:pPr>
               <a:spcBef>
-                <a:spcPts val="800"/>
+                <a:spcPts val="600"/>
               </a:spcBef>
-              <a:defRPr sz="1100">
+              <a:defRPr sz="980">
                 <a:solidFill>
                   <a:srgbClr val="0F172A"/>
                 </a:solidFill>
@@ -3640,9 +3640,9 @@
           <a:p>
             <a:pPr>
               <a:spcBef>
-                <a:spcPts val="800"/>
+                <a:spcPts val="600"/>
               </a:spcBef>
-              <a:defRPr sz="1100">
+              <a:defRPr sz="980">
                 <a:solidFill>
                   <a:srgbClr val="0F172A"/>
                 </a:solidFill>
@@ -3650,642 +3650,45 @@
               </a:defRPr>
             </a:pPr>
             <a:r>
-              <a:t>Key capabilities include High-Frequency 50 FPS Face De-Identification compliant with DPDP Act 2023, Spatial Headcount &amp; Machinery Detection (YOLOv8), 72-Hour Offline Store-and-Forward Telemetry (syncing ultra-light 2-5 KB JSON packets), and Real-Time Timetable Cross-Reconciliation against Skill India Portal rosters. The system delivers automated risk-tiered triage for flying squads and eliminates hundreds of crores in ghost stipend fraud.</a:t>
-            </a:r>
-          </a:p>
-        </p:txBody>
-      </p:sp>
-      <p:sp>
-        <p:nvSpPr>
-          <p:cNvPr id="7" name="Oval 6"/>
-          <p:cNvSpPr/>
+              <a:t>Key capabilities include High-Frequency 50 FPS Face De-Identification (DPDP Act 2023 compliant), Spatial Headcount &amp; Machinery Detection (YOLOv8), 72-Hour Offline Store-and-Forward Telemetry (syncing ultra-light 2-5 KB JSON packets), and Real-Time Timetable Reconciliation against Skill India Portal rosters. The system delivers automated risk-tiered triage for flying squads and eliminates stipend fraud.</a:t>
+            </a:r>
+          </a:p>
+        </p:txBody>
+      </p:sp>
+      <p:pic>
+        <p:nvPicPr>
+          <p:cNvPr id="7" name="Picture 6" descr="slide2_orbital.png"/>
+          <p:cNvPicPr>
+            <a:picLocks noChangeAspect="1"/>
+          </p:cNvPicPr>
           <p:nvPr/>
-        </p:nvSpPr>
-        <p:spPr>
-          <a:xfrm>
-            <a:off x="594360" y="5120640"/>
-            <a:ext cx="822960" cy="822960"/>
-          </a:xfrm>
-          <a:prstGeom prst="ellipse">
+        </p:nvPicPr>
+        <p:blipFill>
+          <a:blip r:embed="rId3"/>
+          <a:stretch>
+            <a:fillRect/>
+          </a:stretch>
+        </p:blipFill>
+        <p:spPr>
+          <a:xfrm>
+            <a:off x="502920" y="4736592"/>
+            <a:ext cx="5577840" cy="1065430"/>
+          </a:xfrm>
+          <a:prstGeom prst="rect">
             <a:avLst/>
           </a:prstGeom>
-          <a:solidFill>
-            <a:srgbClr val="FFFFFF"/>
-          </a:solidFill>
-          <a:ln w="25400">
-            <a:solidFill>
-              <a:srgbClr val="10B981"/>
-            </a:solidFill>
-          </a:ln>
-        </p:spPr>
-        <p:style>
-          <a:lnRef idx="1">
-            <a:schemeClr val="accent1"/>
-          </a:lnRef>
-          <a:fillRef idx="3">
-            <a:schemeClr val="accent1"/>
-          </a:fillRef>
-          <a:effectRef idx="2">
-            <a:schemeClr val="accent1"/>
-          </a:effectRef>
-          <a:fontRef idx="minor">
-            <a:schemeClr val="lt1"/>
-          </a:fontRef>
-        </p:style>
-        <p:txBody>
-          <a:bodyPr rtlCol="0" anchor="ctr" wrap="square"/>
-          <a:lstStyle/>
-          <a:p>
-            <a:pPr algn="ctr">
-              <a:defRPr sz="800" b="1">
-                <a:solidFill>
-                  <a:srgbClr val="10B981"/>
-                </a:solidFill>
-                <a:latin typeface="Arial"/>
-              </a:defRPr>
-            </a:pPr>
-            <a:r>
-              <a:t>Edge Face Blur</a:t>
-            </a:r>
-          </a:p>
-        </p:txBody>
-      </p:sp>
-      <p:sp>
-        <p:nvSpPr>
-          <p:cNvPr id="8" name="Oval 7"/>
-          <p:cNvSpPr/>
-          <p:nvPr/>
-        </p:nvSpPr>
-        <p:spPr>
-          <a:xfrm>
-            <a:off x="1645919" y="5120640"/>
-            <a:ext cx="822960" cy="822960"/>
-          </a:xfrm>
-          <a:prstGeom prst="ellipse">
-            <a:avLst/>
-          </a:prstGeom>
-          <a:solidFill>
-            <a:srgbClr val="FFFFFF"/>
-          </a:solidFill>
-          <a:ln w="25400">
-            <a:solidFill>
-              <a:srgbClr val="0284C7"/>
-            </a:solidFill>
-          </a:ln>
-        </p:spPr>
-        <p:style>
-          <a:lnRef idx="1">
-            <a:schemeClr val="accent1"/>
-          </a:lnRef>
-          <a:fillRef idx="3">
-            <a:schemeClr val="accent1"/>
-          </a:fillRef>
-          <a:effectRef idx="2">
-            <a:schemeClr val="accent1"/>
-          </a:effectRef>
-          <a:fontRef idx="minor">
-            <a:schemeClr val="lt1"/>
-          </a:fontRef>
-        </p:style>
-        <p:txBody>
-          <a:bodyPr rtlCol="0" anchor="ctr" wrap="square"/>
-          <a:lstStyle/>
-          <a:p>
-            <a:pPr algn="ctr">
-              <a:defRPr sz="800" b="1">
-                <a:solidFill>
-                  <a:srgbClr val="0284C7"/>
-                </a:solidFill>
-                <a:latin typeface="Arial"/>
-              </a:defRPr>
-            </a:pPr>
-            <a:r>
-              <a:t>Headcount AI</a:t>
-            </a:r>
-          </a:p>
-        </p:txBody>
-      </p:sp>
-      <p:sp>
-        <p:nvSpPr>
-          <p:cNvPr id="9" name="Oval 8"/>
-          <p:cNvSpPr/>
-          <p:nvPr/>
-        </p:nvSpPr>
-        <p:spPr>
-          <a:xfrm>
-            <a:off x="2697479" y="5120640"/>
-            <a:ext cx="822960" cy="822960"/>
-          </a:xfrm>
-          <a:prstGeom prst="ellipse">
-            <a:avLst/>
-          </a:prstGeom>
-          <a:solidFill>
-            <a:srgbClr val="FFFFFF"/>
-          </a:solidFill>
-          <a:ln w="25400">
-            <a:solidFill>
-              <a:srgbClr val="D97706"/>
-            </a:solidFill>
-          </a:ln>
-        </p:spPr>
-        <p:style>
-          <a:lnRef idx="1">
-            <a:schemeClr val="accent1"/>
-          </a:lnRef>
-          <a:fillRef idx="3">
-            <a:schemeClr val="accent1"/>
-          </a:fillRef>
-          <a:effectRef idx="2">
-            <a:schemeClr val="accent1"/>
-          </a:effectRef>
-          <a:fontRef idx="minor">
-            <a:schemeClr val="lt1"/>
-          </a:fontRef>
-        </p:style>
-        <p:txBody>
-          <a:bodyPr rtlCol="0" anchor="ctr" wrap="square"/>
-          <a:lstStyle/>
-          <a:p>
-            <a:pPr algn="ctr">
-              <a:defRPr sz="800" b="1">
-                <a:solidFill>
-                  <a:srgbClr val="D97706"/>
-                </a:solidFill>
-                <a:latin typeface="Arial"/>
-              </a:defRPr>
-            </a:pPr>
-            <a:r>
-              <a:t>Asset Audit</a:t>
-            </a:r>
-          </a:p>
-        </p:txBody>
-      </p:sp>
-      <p:sp>
-        <p:nvSpPr>
-          <p:cNvPr id="10" name="Oval 9"/>
-          <p:cNvSpPr/>
-          <p:nvPr/>
-        </p:nvSpPr>
-        <p:spPr>
-          <a:xfrm>
-            <a:off x="3749039" y="5120640"/>
-            <a:ext cx="822960" cy="822960"/>
-          </a:xfrm>
-          <a:prstGeom prst="ellipse">
-            <a:avLst/>
-          </a:prstGeom>
-          <a:solidFill>
-            <a:srgbClr val="FFFFFF"/>
-          </a:solidFill>
-          <a:ln w="25400">
-            <a:solidFill>
-              <a:srgbClr val="007E8A"/>
-            </a:solidFill>
-          </a:ln>
-        </p:spPr>
-        <p:style>
-          <a:lnRef idx="1">
-            <a:schemeClr val="accent1"/>
-          </a:lnRef>
-          <a:fillRef idx="3">
-            <a:schemeClr val="accent1"/>
-          </a:fillRef>
-          <a:effectRef idx="2">
-            <a:schemeClr val="accent1"/>
-          </a:effectRef>
-          <a:fontRef idx="minor">
-            <a:schemeClr val="lt1"/>
-          </a:fontRef>
-        </p:style>
-        <p:txBody>
-          <a:bodyPr rtlCol="0" anchor="ctr" wrap="square"/>
-          <a:lstStyle/>
-          <a:p>
-            <a:pPr algn="ctr">
-              <a:defRPr sz="800" b="1">
-                <a:solidFill>
-                  <a:srgbClr val="007E8A"/>
-                </a:solidFill>
-                <a:latin typeface="Arial"/>
-              </a:defRPr>
-            </a:pPr>
-            <a:r>
-              <a:t>2 KB Telemetry</a:t>
-            </a:r>
-          </a:p>
-        </p:txBody>
-      </p:sp>
-      <p:sp>
-        <p:nvSpPr>
-          <p:cNvPr id="11" name="Oval 10"/>
-          <p:cNvSpPr/>
-          <p:nvPr/>
-        </p:nvSpPr>
-        <p:spPr>
-          <a:xfrm>
-            <a:off x="4800600" y="5120640"/>
-            <a:ext cx="822960" cy="822960"/>
-          </a:xfrm>
-          <a:prstGeom prst="ellipse">
-            <a:avLst/>
-          </a:prstGeom>
-          <a:solidFill>
-            <a:srgbClr val="FFFFFF"/>
-          </a:solidFill>
-          <a:ln w="25400">
-            <a:solidFill>
-              <a:srgbClr val="1B365D"/>
-            </a:solidFill>
-          </a:ln>
-        </p:spPr>
-        <p:style>
-          <a:lnRef idx="1">
-            <a:schemeClr val="accent1"/>
-          </a:lnRef>
-          <a:fillRef idx="3">
-            <a:schemeClr val="accent1"/>
-          </a:fillRef>
-          <a:effectRef idx="2">
-            <a:schemeClr val="accent1"/>
-          </a:effectRef>
-          <a:fontRef idx="minor">
-            <a:schemeClr val="lt1"/>
-          </a:fontRef>
-        </p:style>
-        <p:txBody>
-          <a:bodyPr rtlCol="0" anchor="ctr" wrap="square"/>
-          <a:lstStyle/>
-          <a:p>
-            <a:pPr algn="ctr">
-              <a:defRPr sz="800" b="1">
-                <a:solidFill>
-                  <a:srgbClr val="1B365D"/>
-                </a:solidFill>
-                <a:latin typeface="Arial"/>
-              </a:defRPr>
-            </a:pPr>
-            <a:r>
-              <a:t>SIP Reconcile</a:t>
-            </a:r>
-          </a:p>
-        </p:txBody>
-      </p:sp>
-      <p:sp>
-        <p:nvSpPr>
-          <p:cNvPr id="12" name="Rounded Rectangle 11"/>
-          <p:cNvSpPr/>
-          <p:nvPr/>
-        </p:nvSpPr>
-        <p:spPr>
-          <a:xfrm>
-            <a:off x="6492240" y="1005840"/>
-            <a:ext cx="5303520" cy="2468880"/>
-          </a:xfrm>
-          <a:prstGeom prst="roundRect">
-            <a:avLst/>
-          </a:prstGeom>
-          <a:solidFill>
-            <a:srgbClr val="FFFFFF"/>
-          </a:solidFill>
-          <a:ln w="19050">
-            <a:solidFill>
-              <a:srgbClr val="007E8A"/>
-            </a:solidFill>
-          </a:ln>
-        </p:spPr>
-        <p:style>
-          <a:lnRef idx="1">
-            <a:schemeClr val="accent1"/>
-          </a:lnRef>
-          <a:fillRef idx="3">
-            <a:schemeClr val="accent1"/>
-          </a:fillRef>
-          <a:effectRef idx="2">
-            <a:schemeClr val="accent1"/>
-          </a:effectRef>
-          <a:fontRef idx="minor">
-            <a:schemeClr val="lt1"/>
-          </a:fontRef>
-        </p:style>
-        <p:txBody>
-          <a:bodyPr rtlCol="0" anchor="ctr" lIns="228600" tIns="182880"/>
-          <a:lstStyle/>
-          <a:p>
-            <a:pPr algn="ctr">
-              <a:defRPr sz="1400" b="1">
-                <a:solidFill>
-                  <a:srgbClr val="007E8A"/>
-                </a:solidFill>
-                <a:latin typeface="Arial"/>
-              </a:defRPr>
-            </a:pPr>
-            <a:r>
-              <a:t>How it addresses the problem</a:t>
-            </a:r>
-          </a:p>
-        </p:txBody>
-      </p:sp>
-      <p:sp>
-        <p:nvSpPr>
-          <p:cNvPr id="13" name="Rounded Rectangle 12"/>
-          <p:cNvSpPr/>
-          <p:nvPr/>
-        </p:nvSpPr>
-        <p:spPr>
-          <a:xfrm>
-            <a:off x="6675120" y="1554480"/>
-            <a:ext cx="2286000" cy="640080"/>
-          </a:xfrm>
-          <a:prstGeom prst="roundRect">
-            <a:avLst/>
-          </a:prstGeom>
-          <a:solidFill>
-            <a:srgbClr val="F8FAFC"/>
-          </a:solidFill>
-          <a:ln w="12700">
-            <a:solidFill>
-              <a:srgbClr val="0284C7"/>
-            </a:solidFill>
-          </a:ln>
-        </p:spPr>
-        <p:style>
-          <a:lnRef idx="1">
-            <a:schemeClr val="accent1"/>
-          </a:lnRef>
-          <a:fillRef idx="3">
-            <a:schemeClr val="accent1"/>
-          </a:fillRef>
-          <a:effectRef idx="2">
-            <a:schemeClr val="accent1"/>
-          </a:effectRef>
-          <a:fontRef idx="minor">
-            <a:schemeClr val="lt1"/>
-          </a:fontRef>
-        </p:style>
-        <p:txBody>
-          <a:bodyPr rtlCol="0" anchor="ctr" wrap="square"/>
-          <a:lstStyle/>
-          <a:p>
-            <a:pPr algn="ctr">
-              <a:defRPr sz="900" b="1">
-                <a:solidFill>
-                  <a:srgbClr val="0F172A"/>
-                </a:solidFill>
-                <a:latin typeface="Arial"/>
-              </a:defRPr>
-            </a:pPr>
-            <a:r>
-              <a:t>Eliminates Ghost Batches</a:t>
-            </a:r>
-            <a:br/>
-            <a:r>
-              <a:t>(Instant Discrepancy Alerts)</a:t>
-            </a:r>
-          </a:p>
-        </p:txBody>
-      </p:sp>
-      <p:sp>
-        <p:nvSpPr>
-          <p:cNvPr id="14" name="Rounded Rectangle 13"/>
-          <p:cNvSpPr/>
-          <p:nvPr/>
-        </p:nvSpPr>
-        <p:spPr>
-          <a:xfrm>
-            <a:off x="9235440" y="1554480"/>
-            <a:ext cx="2377440" cy="640080"/>
-          </a:xfrm>
-          <a:prstGeom prst="roundRect">
-            <a:avLst/>
-          </a:prstGeom>
-          <a:solidFill>
-            <a:srgbClr val="F8FAFC"/>
-          </a:solidFill>
-          <a:ln w="12700">
-            <a:solidFill>
-              <a:srgbClr val="0284C7"/>
-            </a:solidFill>
-          </a:ln>
-        </p:spPr>
-        <p:style>
-          <a:lnRef idx="1">
-            <a:schemeClr val="accent1"/>
-          </a:lnRef>
-          <a:fillRef idx="3">
-            <a:schemeClr val="accent1"/>
-          </a:fillRef>
-          <a:effectRef idx="2">
-            <a:schemeClr val="accent1"/>
-          </a:effectRef>
-          <a:fontRef idx="minor">
-            <a:schemeClr val="lt1"/>
-          </a:fontRef>
-        </p:style>
-        <p:txBody>
-          <a:bodyPr rtlCol="0" anchor="ctr" wrap="square"/>
-          <a:lstStyle/>
-          <a:p>
-            <a:pPr algn="ctr">
-              <a:defRPr sz="900" b="1">
-                <a:solidFill>
-                  <a:srgbClr val="0F172A"/>
-                </a:solidFill>
-                <a:latin typeface="Arial"/>
-              </a:defRPr>
-            </a:pPr>
-            <a:r>
-              <a:t>Guarantees Quality Training</a:t>
-            </a:r>
-            <a:br/>
-            <a:r>
-              <a:t>(Practical Equipment Check)</a:t>
-            </a:r>
-          </a:p>
-        </p:txBody>
-      </p:sp>
-      <p:sp>
-        <p:nvSpPr>
-          <p:cNvPr id="15" name="Rounded Rectangle 14"/>
-          <p:cNvSpPr/>
-          <p:nvPr/>
-        </p:nvSpPr>
-        <p:spPr>
-          <a:xfrm>
-            <a:off x="6675120" y="2468880"/>
-            <a:ext cx="2286000" cy="640080"/>
-          </a:xfrm>
-          <a:prstGeom prst="roundRect">
-            <a:avLst/>
-          </a:prstGeom>
-          <a:solidFill>
-            <a:srgbClr val="F8FAFC"/>
-          </a:solidFill>
-          <a:ln w="12700">
-            <a:solidFill>
-              <a:srgbClr val="0284C7"/>
-            </a:solidFill>
-          </a:ln>
-        </p:spPr>
-        <p:style>
-          <a:lnRef idx="1">
-            <a:schemeClr val="accent1"/>
-          </a:lnRef>
-          <a:fillRef idx="3">
-            <a:schemeClr val="accent1"/>
-          </a:fillRef>
-          <a:effectRef idx="2">
-            <a:schemeClr val="accent1"/>
-          </a:effectRef>
-          <a:fontRef idx="minor">
-            <a:schemeClr val="lt1"/>
-          </a:fontRef>
-        </p:style>
-        <p:txBody>
-          <a:bodyPr rtlCol="0" anchor="ctr" wrap="square"/>
-          <a:lstStyle/>
-          <a:p>
-            <a:pPr algn="ctr">
-              <a:defRPr sz="900" b="1">
-                <a:solidFill>
-                  <a:srgbClr val="0F172A"/>
-                </a:solidFill>
-                <a:latin typeface="Arial"/>
-              </a:defRPr>
-            </a:pPr>
-            <a:r>
-              <a:t>99.4% Bandwidth Savings</a:t>
-            </a:r>
-            <a:br/>
-            <a:r>
-              <a:t>(2G/3G Dongle Compatible)</a:t>
-            </a:r>
-          </a:p>
-        </p:txBody>
-      </p:sp>
-      <p:sp>
-        <p:nvSpPr>
-          <p:cNvPr id="16" name="Rounded Rectangle 15"/>
-          <p:cNvSpPr/>
-          <p:nvPr/>
-        </p:nvSpPr>
-        <p:spPr>
-          <a:xfrm>
-            <a:off x="9235440" y="2468880"/>
-            <a:ext cx="2377440" cy="640080"/>
-          </a:xfrm>
-          <a:prstGeom prst="roundRect">
-            <a:avLst/>
-          </a:prstGeom>
-          <a:solidFill>
-            <a:srgbClr val="F8FAFC"/>
-          </a:solidFill>
-          <a:ln w="12700">
-            <a:solidFill>
-              <a:srgbClr val="0284C7"/>
-            </a:solidFill>
-          </a:ln>
-        </p:spPr>
-        <p:style>
-          <a:lnRef idx="1">
-            <a:schemeClr val="accent1"/>
-          </a:lnRef>
-          <a:fillRef idx="3">
-            <a:schemeClr val="accent1"/>
-          </a:fillRef>
-          <a:effectRef idx="2">
-            <a:schemeClr val="accent1"/>
-          </a:effectRef>
-          <a:fontRef idx="minor">
-            <a:schemeClr val="lt1"/>
-          </a:fontRef>
-        </p:style>
-        <p:txBody>
-          <a:bodyPr rtlCol="0" anchor="ctr" wrap="square"/>
-          <a:lstStyle/>
-          <a:p>
-            <a:pPr algn="ctr">
-              <a:defRPr sz="900" b="1">
-                <a:solidFill>
-                  <a:srgbClr val="0F172A"/>
-                </a:solidFill>
-                <a:latin typeface="Arial"/>
-              </a:defRPr>
-            </a:pPr>
-            <a:r>
-              <a:t>100% DPDP Act Compliant</a:t>
-            </a:r>
-            <a:br/>
-            <a:r>
-              <a:t>(Zero Biometric Face Storage)</a:t>
-            </a:r>
-          </a:p>
-        </p:txBody>
-      </p:sp>
-      <p:sp>
-        <p:nvSpPr>
-          <p:cNvPr id="17" name="Rounded Rectangle 16"/>
-          <p:cNvSpPr/>
-          <p:nvPr/>
-        </p:nvSpPr>
-        <p:spPr>
-          <a:xfrm>
-            <a:off x="6492240" y="3657600"/>
-            <a:ext cx="5303520" cy="2651760"/>
-          </a:xfrm>
-          <a:prstGeom prst="roundRect">
-            <a:avLst/>
-          </a:prstGeom>
-          <a:solidFill>
-            <a:srgbClr val="FFFFFF"/>
-          </a:solidFill>
-          <a:ln w="19050">
-            <a:solidFill>
-              <a:srgbClr val="007E8A"/>
-            </a:solidFill>
-          </a:ln>
-        </p:spPr>
-        <p:style>
-          <a:lnRef idx="1">
-            <a:schemeClr val="accent1"/>
-          </a:lnRef>
-          <a:fillRef idx="3">
-            <a:schemeClr val="accent1"/>
-          </a:fillRef>
-          <a:effectRef idx="2">
-            <a:schemeClr val="accent1"/>
-          </a:effectRef>
-          <a:fontRef idx="minor">
-            <a:schemeClr val="lt1"/>
-          </a:fontRef>
-        </p:style>
-        <p:txBody>
-          <a:bodyPr rtlCol="0" anchor="ctr" lIns="228600" tIns="182880"/>
-          <a:lstStyle/>
-          <a:p>
-            <a:pPr algn="ctr">
-              <a:defRPr sz="1400" b="1">
-                <a:solidFill>
-                  <a:srgbClr val="007E8A"/>
-                </a:solidFill>
-                <a:latin typeface="Arial"/>
-              </a:defRPr>
-            </a:pPr>
-            <a:r>
-              <a:t>Innovation and uniqueness of the solution</a:t>
-            </a:r>
-          </a:p>
-        </p:txBody>
-      </p:sp>
-      <p:sp>
-        <p:nvSpPr>
-          <p:cNvPr id="18" name="TextBox 17"/>
+        </p:spPr>
+      </p:pic>
+      <p:sp>
+        <p:nvSpPr>
+          <p:cNvPr id="8" name="TextBox 7"/>
           <p:cNvSpPr txBox="1"/>
           <p:nvPr/>
         </p:nvSpPr>
         <p:spPr>
           <a:xfrm>
-            <a:off x="6675120" y="4114800"/>
-            <a:ext cx="4937760" cy="365760"/>
+            <a:off x="6492240" y="960120"/>
+            <a:ext cx="5303520" cy="320040"/>
           </a:xfrm>
           <a:prstGeom prst="rect">
             <a:avLst/>
@@ -4298,35 +3701,54 @@
           </a:bodyPr>
           <a:lstStyle/>
           <a:p>
-            <a:r>
-              <a:rPr b="1" sz="1000">
-                <a:solidFill>
-                  <a:srgbClr val="0284C7"/>
-                </a:solidFill>
-              </a:rPr>
-              <a:t>🔒 50 FPS Edge De-ID: </a:t>
-            </a:r>
-            <a:r>
-              <a:rPr sz="950">
-                <a:solidFill>
-                  <a:srgbClr val="475569"/>
-                </a:solidFill>
-              </a:rPr>
-              <a:t>Zero facial exposure; DPDP 2023 certified blur filter</a:t>
-            </a:r>
-          </a:p>
-        </p:txBody>
-      </p:sp>
-      <p:sp>
-        <p:nvSpPr>
-          <p:cNvPr id="19" name="TextBox 18"/>
+            <a:pPr>
+              <a:defRPr sz="1300" b="1">
+                <a:solidFill>
+                  <a:srgbClr val="007E8A"/>
+                </a:solidFill>
+                <a:latin typeface="Arial"/>
+              </a:defRPr>
+            </a:pPr>
+            <a:r>
+              <a:t>How it addresses the problem</a:t>
+            </a:r>
+          </a:p>
+        </p:txBody>
+      </p:sp>
+      <p:pic>
+        <p:nvPicPr>
+          <p:cNvPr id="9" name="Picture 8" descr="slide2_workflow.png"/>
+          <p:cNvPicPr>
+            <a:picLocks noChangeAspect="1"/>
+          </p:cNvPicPr>
+          <p:nvPr/>
+        </p:nvPicPr>
+        <p:blipFill>
+          <a:blip r:embed="rId4"/>
+          <a:stretch>
+            <a:fillRect/>
+          </a:stretch>
+        </p:blipFill>
+        <p:spPr>
+          <a:xfrm>
+            <a:off x="6492240" y="1298448"/>
+            <a:ext cx="5303520" cy="2083526"/>
+          </a:xfrm>
+          <a:prstGeom prst="rect">
+            <a:avLst/>
+          </a:prstGeom>
+        </p:spPr>
+      </p:pic>
+      <p:sp>
+        <p:nvSpPr>
+          <p:cNvPr id="10" name="TextBox 9"/>
           <p:cNvSpPr txBox="1"/>
           <p:nvPr/>
         </p:nvSpPr>
         <p:spPr>
           <a:xfrm>
-            <a:off x="6675120" y="4498848"/>
-            <a:ext cx="4937760" cy="365760"/>
+            <a:off x="6492240" y="3547872"/>
+            <a:ext cx="5303520" cy="320040"/>
           </a:xfrm>
           <a:prstGeom prst="rect">
             <a:avLst/>
@@ -4339,35 +3761,54 @@
           </a:bodyPr>
           <a:lstStyle/>
           <a:p>
-            <a:r>
-              <a:rPr b="1" sz="1000">
-                <a:solidFill>
-                  <a:srgbClr val="0284C7"/>
-                </a:solidFill>
-              </a:rPr>
-              <a:t>⚡ 2-5 KB Telemetry: </a:t>
-            </a:r>
-            <a:r>
-              <a:rPr sz="950">
-                <a:solidFill>
-                  <a:srgbClr val="475569"/>
-                </a:solidFill>
-              </a:rPr>
-              <a:t>120 MB/month per centre; saves 99.4% cloud streaming cost</a:t>
-            </a:r>
-          </a:p>
-        </p:txBody>
-      </p:sp>
-      <p:sp>
-        <p:nvSpPr>
-          <p:cNvPr id="20" name="TextBox 19"/>
+            <a:pPr>
+              <a:defRPr sz="1300" b="1">
+                <a:solidFill>
+                  <a:srgbClr val="007E8A"/>
+                </a:solidFill>
+                <a:latin typeface="Arial"/>
+              </a:defRPr>
+            </a:pPr>
+            <a:r>
+              <a:t>Innovation and uniqueness of the solution</a:t>
+            </a:r>
+          </a:p>
+        </p:txBody>
+      </p:sp>
+      <p:pic>
+        <p:nvPicPr>
+          <p:cNvPr id="11" name="Picture 10" descr="slide2_innovations.png"/>
+          <p:cNvPicPr>
+            <a:picLocks noChangeAspect="1"/>
+          </p:cNvPicPr>
+          <p:nvPr/>
+        </p:nvPicPr>
+        <p:blipFill>
+          <a:blip r:embed="rId5"/>
+          <a:stretch>
+            <a:fillRect/>
+          </a:stretch>
+        </p:blipFill>
+        <p:spPr>
+          <a:xfrm>
+            <a:off x="6492240" y="3886200"/>
+            <a:ext cx="5303520" cy="2083526"/>
+          </a:xfrm>
+          <a:prstGeom prst="rect">
+            <a:avLst/>
+          </a:prstGeom>
+        </p:spPr>
+      </p:pic>
+      <p:sp>
+        <p:nvSpPr>
+          <p:cNvPr id="12" name="TextBox 11"/>
           <p:cNvSpPr txBox="1"/>
           <p:nvPr/>
         </p:nvSpPr>
         <p:spPr>
           <a:xfrm>
-            <a:off x="6675120" y="4882896"/>
-            <a:ext cx="4937760" cy="365760"/>
+            <a:off x="6492240" y="6172200"/>
+            <a:ext cx="4572000" cy="320040"/>
           </a:xfrm>
           <a:prstGeom prst="rect">
             <a:avLst/>
@@ -4380,131 +3821,8 @@
           </a:bodyPr>
           <a:lstStyle/>
           <a:p>
-            <a:r>
-              <a:rPr b="1" sz="1000">
-                <a:solidFill>
-                  <a:srgbClr val="0284C7"/>
-                </a:solidFill>
-              </a:rPr>
-              <a:t>💾 72-Hr Store &amp; Forward: </a:t>
-            </a:r>
-            <a:r>
-              <a:rPr sz="950">
-                <a:solidFill>
-                  <a:srgbClr val="475569"/>
-                </a:solidFill>
-              </a:rPr>
-              <a:t>Local SQLite caching guarantees zero data loss in rural outages</a:t>
-            </a:r>
-          </a:p>
-        </p:txBody>
-      </p:sp>
-      <p:sp>
-        <p:nvSpPr>
-          <p:cNvPr id="21" name="TextBox 20"/>
-          <p:cNvSpPr txBox="1"/>
-          <p:nvPr/>
-        </p:nvSpPr>
-        <p:spPr>
-          <a:xfrm>
-            <a:off x="6675120" y="5266944"/>
-            <a:ext cx="4937760" cy="365760"/>
-          </a:xfrm>
-          <a:prstGeom prst="rect">
-            <a:avLst/>
-          </a:prstGeom>
-          <a:noFill/>
-        </p:spPr>
-        <p:txBody>
-          <a:bodyPr wrap="none" lIns="0" tIns="0">
-            <a:spAutoFit/>
-          </a:bodyPr>
-          <a:lstStyle/>
-          <a:p>
-            <a:r>
-              <a:rPr b="1" sz="1000">
-                <a:solidFill>
-                  <a:srgbClr val="0284C7"/>
-                </a:solidFill>
-              </a:rPr>
-              <a:t>🛠 Spatial Tool Audit: </a:t>
-            </a:r>
-            <a:r>
-              <a:rPr sz="950">
-                <a:solidFill>
-                  <a:srgbClr val="475569"/>
-                </a:solidFill>
-              </a:rPr>
-              <a:t>YOLOv8 verifies mandatory sanctioned workbenches &amp; kits</a:t>
-            </a:r>
-          </a:p>
-        </p:txBody>
-      </p:sp>
-      <p:sp>
-        <p:nvSpPr>
-          <p:cNvPr id="22" name="TextBox 21"/>
-          <p:cNvSpPr txBox="1"/>
-          <p:nvPr/>
-        </p:nvSpPr>
-        <p:spPr>
-          <a:xfrm>
-            <a:off x="6675120" y="5650992"/>
-            <a:ext cx="4937760" cy="365760"/>
-          </a:xfrm>
-          <a:prstGeom prst="rect">
-            <a:avLst/>
-          </a:prstGeom>
-          <a:noFill/>
-        </p:spPr>
-        <p:txBody>
-          <a:bodyPr wrap="none" lIns="0" tIns="0">
-            <a:spAutoFit/>
-          </a:bodyPr>
-          <a:lstStyle/>
-          <a:p>
-            <a:r>
-              <a:rPr b="1" sz="1000">
-                <a:solidFill>
-                  <a:srgbClr val="0284C7"/>
-                </a:solidFill>
-              </a:rPr>
-              <a:t>🗺 Live GIS Portal: </a:t>
-            </a:r>
-            <a:r>
-              <a:rPr sz="950">
-                <a:solidFill>
-                  <a:srgbClr val="475569"/>
-                </a:solidFill>
-              </a:rPr>
-              <a:t>Interactive MSDE map with Scrypt/JWT tamper-proof audit trails</a:t>
-            </a:r>
-          </a:p>
-        </p:txBody>
-      </p:sp>
-      <p:sp>
-        <p:nvSpPr>
-          <p:cNvPr id="23" name="TextBox 22"/>
-          <p:cNvSpPr txBox="1"/>
-          <p:nvPr/>
-        </p:nvSpPr>
-        <p:spPr>
-          <a:xfrm>
-            <a:off x="6675120" y="5989320"/>
-            <a:ext cx="4937760" cy="320040"/>
-          </a:xfrm>
-          <a:prstGeom prst="rect">
-            <a:avLst/>
-          </a:prstGeom>
-          <a:noFill/>
-        </p:spPr>
-        <p:txBody>
-          <a:bodyPr wrap="none" lIns="0" tIns="0">
-            <a:spAutoFit/>
-          </a:bodyPr>
-          <a:lstStyle/>
-          <a:p>
-            <a:pPr algn="r">
-              <a:defRPr sz="1000" b="1">
+            <a:pPr algn="l">
+              <a:defRPr sz="950" b="1">
                 <a:solidFill>
                   <a:srgbClr val="0284C7"/>
                 </a:solidFill>
@@ -4728,7 +4046,7 @@
           <a:lstStyle/>
           <a:p>
             <a:pPr algn="ctr">
-              <a:defRPr b="1" sz="1100">
+              <a:defRPr b="1" sz="1050">
                 <a:solidFill>
                   <a:srgbClr val="10B981"/>
                 </a:solidFill>
@@ -4740,7 +4058,7 @@
           </a:p>
           <a:p>
             <a:pPr>
-              <a:defRPr sz="900">
+              <a:defRPr sz="850">
                 <a:solidFill>
                   <a:srgbClr val="0F172A"/>
                 </a:solidFill>
@@ -4752,7 +4070,7 @@
           </a:p>
           <a:p>
             <a:pPr>
-              <a:defRPr sz="900">
+              <a:defRPr sz="850">
                 <a:solidFill>
                   <a:srgbClr val="0F172A"/>
                 </a:solidFill>
@@ -4764,7 +4082,7 @@
           </a:p>
           <a:p>
             <a:pPr>
-              <a:defRPr sz="900">
+              <a:defRPr sz="850">
                 <a:solidFill>
                   <a:srgbClr val="0F172A"/>
                 </a:solidFill>
@@ -4818,7 +4136,7 @@
           <a:lstStyle/>
           <a:p>
             <a:pPr algn="ctr">
-              <a:defRPr b="1" sz="1100">
+              <a:defRPr b="1" sz="1050">
                 <a:solidFill>
                   <a:srgbClr val="0284C7"/>
                 </a:solidFill>
@@ -4830,7 +4148,7 @@
           </a:p>
           <a:p>
             <a:pPr>
-              <a:defRPr sz="900">
+              <a:defRPr sz="850">
                 <a:solidFill>
                   <a:srgbClr val="0F172A"/>
                 </a:solidFill>
@@ -4842,7 +4160,7 @@
           </a:p>
           <a:p>
             <a:pPr>
-              <a:defRPr sz="900">
+              <a:defRPr sz="850">
                 <a:solidFill>
                   <a:srgbClr val="0F172A"/>
                 </a:solidFill>
@@ -4854,7 +4172,7 @@
           </a:p>
           <a:p>
             <a:pPr>
-              <a:defRPr sz="900">
+              <a:defRPr sz="850">
                 <a:solidFill>
                   <a:srgbClr val="0F172A"/>
                 </a:solidFill>
@@ -4908,7 +4226,7 @@
           <a:lstStyle/>
           <a:p>
             <a:pPr algn="ctr">
-              <a:defRPr b="1" sz="1100">
+              <a:defRPr b="1" sz="1050">
                 <a:solidFill>
                   <a:srgbClr val="D97706"/>
                 </a:solidFill>
@@ -4920,7 +4238,7 @@
           </a:p>
           <a:p>
             <a:pPr>
-              <a:defRPr sz="900">
+              <a:defRPr sz="850">
                 <a:solidFill>
                   <a:srgbClr val="0F172A"/>
                 </a:solidFill>
@@ -4932,7 +4250,7 @@
           </a:p>
           <a:p>
             <a:pPr>
-              <a:defRPr sz="900">
+              <a:defRPr sz="850">
                 <a:solidFill>
                   <a:srgbClr val="0F172A"/>
                 </a:solidFill>
@@ -4944,7 +4262,7 @@
           </a:p>
           <a:p>
             <a:pPr>
-              <a:defRPr sz="900">
+              <a:defRPr sz="850">
                 <a:solidFill>
                   <a:srgbClr val="0F172A"/>
                 </a:solidFill>
@@ -4998,7 +4316,7 @@
           <a:lstStyle/>
           <a:p>
             <a:pPr algn="ctr">
-              <a:defRPr b="1" sz="1100">
+              <a:defRPr b="1" sz="1050">
                 <a:solidFill>
                   <a:srgbClr val="007E8A"/>
                 </a:solidFill>
@@ -5010,7 +4328,7 @@
           </a:p>
           <a:p>
             <a:pPr>
-              <a:defRPr sz="900">
+              <a:defRPr sz="850">
                 <a:solidFill>
                   <a:srgbClr val="0F172A"/>
                 </a:solidFill>
@@ -5022,7 +4340,7 @@
           </a:p>
           <a:p>
             <a:pPr>
-              <a:defRPr sz="900">
+              <a:defRPr sz="850">
                 <a:solidFill>
                   <a:srgbClr val="0F172A"/>
                 </a:solidFill>
@@ -5034,7 +4352,7 @@
           </a:p>
           <a:p>
             <a:pPr>
-              <a:defRPr sz="900">
+              <a:defRPr sz="850">
                 <a:solidFill>
                   <a:srgbClr val="0F172A"/>
                 </a:solidFill>
@@ -5084,7 +4402,7 @@
           </a:fontRef>
         </p:style>
         <p:txBody>
-          <a:bodyPr rtlCol="0" anchor="ctr" lIns="228600" tIns="182880"/>
+          <a:bodyPr rtlCol="0" anchor="ctr" lIns="228600" tIns="164592"/>
           <a:lstStyle/>
           <a:p>
             <a:pPr algn="ctr">
@@ -5101,9 +4419,9 @@
           <a:p>
             <a:pPr>
               <a:spcBef>
-                <a:spcPts val="600"/>
+                <a:spcPts val="500"/>
               </a:spcBef>
-              <a:defRPr b="1" sz="1050">
+              <a:defRPr b="1" sz="1000">
                 <a:solidFill>
                   <a:srgbClr val="1B365D"/>
                 </a:solidFill>
@@ -5115,7 +4433,7 @@
           </a:p>
           <a:p>
             <a:pPr>
-              <a:defRPr sz="900">
+              <a:defRPr sz="850">
                 <a:solidFill>
                   <a:srgbClr val="0F172A"/>
                 </a:solidFill>
@@ -5127,7 +4445,7 @@
           </a:p>
           <a:p>
             <a:pPr>
-              <a:defRPr sz="900">
+              <a:defRPr sz="850">
                 <a:solidFill>
                   <a:srgbClr val="0F172A"/>
                 </a:solidFill>
@@ -5139,7 +4457,7 @@
           </a:p>
           <a:p>
             <a:pPr>
-              <a:defRPr sz="900">
+              <a:defRPr sz="850">
                 <a:solidFill>
                   <a:srgbClr val="0F172A"/>
                 </a:solidFill>
@@ -5152,9 +4470,9 @@
           <a:p>
             <a:pPr>
               <a:spcBef>
-                <a:spcPts val="600"/>
+                <a:spcPts val="500"/>
               </a:spcBef>
-              <a:defRPr b="1" sz="1050">
+              <a:defRPr b="1" sz="1000">
                 <a:solidFill>
                   <a:srgbClr val="1B365D"/>
                 </a:solidFill>
@@ -5166,7 +4484,7 @@
           </a:p>
           <a:p>
             <a:pPr>
-              <a:defRPr sz="900">
+              <a:defRPr sz="850">
                 <a:solidFill>
                   <a:srgbClr val="0F172A"/>
                 </a:solidFill>
@@ -5178,7 +4496,7 @@
           </a:p>
           <a:p>
             <a:pPr>
-              <a:defRPr sz="900">
+              <a:defRPr sz="850">
                 <a:solidFill>
                   <a:srgbClr val="0F172A"/>
                 </a:solidFill>
@@ -5190,7 +4508,7 @@
           </a:p>
           <a:p>
             <a:pPr>
-              <a:defRPr sz="900">
+              <a:defRPr sz="850">
                 <a:solidFill>
                   <a:srgbClr val="0F172A"/>
                 </a:solidFill>
@@ -5202,562 +4520,30 @@
           </a:p>
         </p:txBody>
       </p:sp>
-      <p:sp>
-        <p:nvSpPr>
-          <p:cNvPr id="11" name="Rounded Rectangle 10"/>
-          <p:cNvSpPr/>
+      <p:pic>
+        <p:nvPicPr>
+          <p:cNvPr id="11" name="Picture 10" descr="slide3_architecture.png"/>
+          <p:cNvPicPr>
+            <a:picLocks noChangeAspect="1"/>
+          </p:cNvPicPr>
           <p:nvPr/>
-        </p:nvSpPr>
-        <p:spPr>
-          <a:xfrm>
-            <a:off x="6309360" y="1005840"/>
-            <a:ext cx="5486400" cy="5303520"/>
-          </a:xfrm>
-          <a:prstGeom prst="roundRect">
+        </p:nvPicPr>
+        <p:blipFill>
+          <a:blip r:embed="rId3"/>
+          <a:stretch>
+            <a:fillRect/>
+          </a:stretch>
+        </p:blipFill>
+        <p:spPr>
+          <a:xfrm>
+            <a:off x="6217920" y="1005840"/>
+            <a:ext cx="5577840" cy="4666078"/>
+          </a:xfrm>
+          <a:prstGeom prst="rect">
             <a:avLst/>
           </a:prstGeom>
-          <a:solidFill>
-            <a:srgbClr val="F8FAFC"/>
-          </a:solidFill>
-          <a:ln w="19050">
-            <a:solidFill>
-              <a:srgbClr val="0284C7"/>
-            </a:solidFill>
-          </a:ln>
-        </p:spPr>
-        <p:style>
-          <a:lnRef idx="1">
-            <a:schemeClr val="accent1"/>
-          </a:lnRef>
-          <a:fillRef idx="3">
-            <a:schemeClr val="accent1"/>
-          </a:fillRef>
-          <a:effectRef idx="2">
-            <a:schemeClr val="accent1"/>
-          </a:effectRef>
-          <a:fontRef idx="minor">
-            <a:schemeClr val="lt1"/>
-          </a:fontRef>
-        </p:style>
-        <p:txBody>
-          <a:bodyPr rtlCol="0" anchor="ctr" lIns="228600" tIns="182880"/>
-          <a:lstStyle/>
-          <a:p>
-            <a:pPr algn="ctr">
-              <a:defRPr b="1" sz="1400">
-                <a:solidFill>
-                  <a:srgbClr val="1B365D"/>
-                </a:solidFill>
-              </a:defRPr>
-            </a:pPr>
-            <a:r>
-              <a:t>End-to-End System Pipeline Architecture</a:t>
-            </a:r>
-          </a:p>
-        </p:txBody>
-      </p:sp>
-      <p:sp>
-        <p:nvSpPr>
-          <p:cNvPr id="12" name="Rounded Rectangle 11"/>
-          <p:cNvSpPr/>
-          <p:nvPr/>
-        </p:nvSpPr>
-        <p:spPr>
-          <a:xfrm>
-            <a:off x="6492240" y="1554480"/>
-            <a:ext cx="5120640" cy="658368"/>
-          </a:xfrm>
-          <a:prstGeom prst="roundRect">
-            <a:avLst/>
-          </a:prstGeom>
-          <a:solidFill>
-            <a:srgbClr val="FFFFFF"/>
-          </a:solidFill>
-          <a:ln w="19050">
-            <a:solidFill>
-              <a:srgbClr val="1B365D"/>
-            </a:solidFill>
-          </a:ln>
-        </p:spPr>
-        <p:style>
-          <a:lnRef idx="1">
-            <a:schemeClr val="accent1"/>
-          </a:lnRef>
-          <a:fillRef idx="3">
-            <a:schemeClr val="accent1"/>
-          </a:fillRef>
-          <a:effectRef idx="2">
-            <a:schemeClr val="accent1"/>
-          </a:effectRef>
-          <a:fontRef idx="minor">
-            <a:schemeClr val="lt1"/>
-          </a:fontRef>
-        </p:style>
-        <p:txBody>
-          <a:bodyPr rtlCol="0" anchor="ctr" lIns="182880"/>
-          <a:lstStyle/>
-          <a:p>
-            <a:pPr algn="ctr">
-              <a:defRPr b="1" sz="1050">
-                <a:solidFill>
-                  <a:srgbClr val="1B365D"/>
-                </a:solidFill>
-              </a:defRPr>
-            </a:pPr>
-            <a:r>
-              <a:t>1. CCTV Sensing &amp; Ingestion</a:t>
-            </a:r>
-          </a:p>
-          <a:p>
-            <a:pPr>
-              <a:defRPr sz="850">
-                <a:solidFill>
-                  <a:srgbClr val="475569"/>
-                </a:solidFill>
-              </a:defRPr>
-            </a:pPr>
-            <a:r>
-              <a:t>RTSP 720p/1080p Stream • Anti-Tamper Frame Angle Guard</a:t>
-            </a:r>
-          </a:p>
-        </p:txBody>
-      </p:sp>
-      <p:sp>
-        <p:nvSpPr>
-          <p:cNvPr id="13" name="Rounded Rectangle 12"/>
-          <p:cNvSpPr/>
-          <p:nvPr/>
-        </p:nvSpPr>
-        <p:spPr>
-          <a:xfrm>
-            <a:off x="6492240" y="2377440"/>
-            <a:ext cx="5120640" cy="658368"/>
-          </a:xfrm>
-          <a:prstGeom prst="roundRect">
-            <a:avLst/>
-          </a:prstGeom>
-          <a:solidFill>
-            <a:srgbClr val="FFFFFF"/>
-          </a:solidFill>
-          <a:ln w="19050">
-            <a:solidFill>
-              <a:srgbClr val="10B981"/>
-            </a:solidFill>
-          </a:ln>
-        </p:spPr>
-        <p:style>
-          <a:lnRef idx="1">
-            <a:schemeClr val="accent1"/>
-          </a:lnRef>
-          <a:fillRef idx="3">
-            <a:schemeClr val="accent1"/>
-          </a:fillRef>
-          <a:effectRef idx="2">
-            <a:schemeClr val="accent1"/>
-          </a:effectRef>
-          <a:fontRef idx="minor">
-            <a:schemeClr val="lt1"/>
-          </a:fontRef>
-        </p:style>
-        <p:txBody>
-          <a:bodyPr rtlCol="0" anchor="ctr" lIns="182880"/>
-          <a:lstStyle/>
-          <a:p>
-            <a:pPr algn="ctr">
-              <a:defRPr b="1" sz="1050">
-                <a:solidFill>
-                  <a:srgbClr val="10B981"/>
-                </a:solidFill>
-              </a:defRPr>
-            </a:pPr>
-            <a:r>
-              <a:t>2. Edge AI &amp; Privacy Shield</a:t>
-            </a:r>
-          </a:p>
-          <a:p>
-            <a:pPr>
-              <a:defRPr sz="850">
-                <a:solidFill>
-                  <a:srgbClr val="475569"/>
-                </a:solidFill>
-              </a:defRPr>
-            </a:pPr>
-            <a:r>
-              <a:t>50 FPS BlazeFace Blur • YOLOv8 Headcount • Tool Verification</a:t>
-            </a:r>
-          </a:p>
-        </p:txBody>
-      </p:sp>
-      <p:sp>
-        <p:nvSpPr>
-          <p:cNvPr id="14" name="Rounded Rectangle 13"/>
-          <p:cNvSpPr/>
-          <p:nvPr/>
-        </p:nvSpPr>
-        <p:spPr>
-          <a:xfrm>
-            <a:off x="6492240" y="3200400"/>
-            <a:ext cx="5120640" cy="658368"/>
-          </a:xfrm>
-          <a:prstGeom prst="roundRect">
-            <a:avLst/>
-          </a:prstGeom>
-          <a:solidFill>
-            <a:srgbClr val="FFFFFF"/>
-          </a:solidFill>
-          <a:ln w="19050">
-            <a:solidFill>
-              <a:srgbClr val="007E8A"/>
-            </a:solidFill>
-          </a:ln>
-        </p:spPr>
-        <p:style>
-          <a:lnRef idx="1">
-            <a:schemeClr val="accent1"/>
-          </a:lnRef>
-          <a:fillRef idx="3">
-            <a:schemeClr val="accent1"/>
-          </a:fillRef>
-          <a:effectRef idx="2">
-            <a:schemeClr val="accent1"/>
-          </a:effectRef>
-          <a:fontRef idx="minor">
-            <a:schemeClr val="lt1"/>
-          </a:fontRef>
-        </p:style>
-        <p:txBody>
-          <a:bodyPr rtlCol="0" anchor="ctr" lIns="182880"/>
-          <a:lstStyle/>
-          <a:p>
-            <a:pPr algn="ctr">
-              <a:defRPr b="1" sz="1050">
-                <a:solidFill>
-                  <a:srgbClr val="007E8A"/>
-                </a:solidFill>
-              </a:defRPr>
-            </a:pPr>
-            <a:r>
-              <a:t>3. Lightweight Transport</a:t>
-            </a:r>
-          </a:p>
-          <a:p>
-            <a:pPr>
-              <a:defRPr sz="850">
-                <a:solidFill>
-                  <a:srgbClr val="475569"/>
-                </a:solidFill>
-              </a:defRPr>
-            </a:pPr>
-            <a:r>
-              <a:t>Encrypted 2-5 KB JSON Telemetry • 72-Hr SQLite Buffer</a:t>
-            </a:r>
-          </a:p>
-        </p:txBody>
-      </p:sp>
-      <p:sp>
-        <p:nvSpPr>
-          <p:cNvPr id="15" name="Rounded Rectangle 14"/>
-          <p:cNvSpPr/>
-          <p:nvPr/>
-        </p:nvSpPr>
-        <p:spPr>
-          <a:xfrm>
-            <a:off x="6492240" y="4023360"/>
-            <a:ext cx="5120640" cy="658368"/>
-          </a:xfrm>
-          <a:prstGeom prst="roundRect">
-            <a:avLst/>
-          </a:prstGeom>
-          <a:solidFill>
-            <a:srgbClr val="FFFFFF"/>
-          </a:solidFill>
-          <a:ln w="19050">
-            <a:solidFill>
-              <a:srgbClr val="D97706"/>
-            </a:solidFill>
-          </a:ln>
-        </p:spPr>
-        <p:style>
-          <a:lnRef idx="1">
-            <a:schemeClr val="accent1"/>
-          </a:lnRef>
-          <a:fillRef idx="3">
-            <a:schemeClr val="accent1"/>
-          </a:fillRef>
-          <a:effectRef idx="2">
-            <a:schemeClr val="accent1"/>
-          </a:effectRef>
-          <a:fontRef idx="minor">
-            <a:schemeClr val="lt1"/>
-          </a:fontRef>
-        </p:style>
-        <p:txBody>
-          <a:bodyPr rtlCol="0" anchor="ctr" lIns="182880"/>
-          <a:lstStyle/>
-          <a:p>
-            <a:pPr algn="ctr">
-              <a:defRPr b="1" sz="1050">
-                <a:solidFill>
-                  <a:srgbClr val="D97706"/>
-                </a:solidFill>
-              </a:defRPr>
-            </a:pPr>
-            <a:r>
-              <a:t>4. Cloud Reconciliation Engine</a:t>
-            </a:r>
-          </a:p>
-          <a:p>
-            <a:pPr>
-              <a:defRPr sz="850">
-                <a:solidFill>
-                  <a:srgbClr val="475569"/>
-                </a:solidFill>
-              </a:defRPr>
-            </a:pPr>
-            <a:r>
-              <a:t>SIP Timetable Matcher • Discrepancy Rate: |Claimed - Real|</a:t>
-            </a:r>
-          </a:p>
-        </p:txBody>
-      </p:sp>
-      <p:sp>
-        <p:nvSpPr>
-          <p:cNvPr id="16" name="Rounded Rectangle 15"/>
-          <p:cNvSpPr/>
-          <p:nvPr/>
-        </p:nvSpPr>
-        <p:spPr>
-          <a:xfrm>
-            <a:off x="6492240" y="4846320"/>
-            <a:ext cx="5120640" cy="658368"/>
-          </a:xfrm>
-          <a:prstGeom prst="roundRect">
-            <a:avLst/>
-          </a:prstGeom>
-          <a:solidFill>
-            <a:srgbClr val="FFFFFF"/>
-          </a:solidFill>
-          <a:ln w="19050">
-            <a:solidFill>
-              <a:srgbClr val="0284C7"/>
-            </a:solidFill>
-          </a:ln>
-        </p:spPr>
-        <p:style>
-          <a:lnRef idx="1">
-            <a:schemeClr val="accent1"/>
-          </a:lnRef>
-          <a:fillRef idx="3">
-            <a:schemeClr val="accent1"/>
-          </a:fillRef>
-          <a:effectRef idx="2">
-            <a:schemeClr val="accent1"/>
-          </a:effectRef>
-          <a:fontRef idx="minor">
-            <a:schemeClr val="lt1"/>
-          </a:fontRef>
-        </p:style>
-        <p:txBody>
-          <a:bodyPr rtlCol="0" anchor="ctr" lIns="182880"/>
-          <a:lstStyle/>
-          <a:p>
-            <a:pPr algn="ctr">
-              <a:defRPr b="1" sz="1050">
-                <a:solidFill>
-                  <a:srgbClr val="0284C7"/>
-                </a:solidFill>
-              </a:defRPr>
-            </a:pPr>
-            <a:r>
-              <a:t>5. MSDE National Dashboard</a:t>
-            </a:r>
-          </a:p>
-          <a:p>
-            <a:pPr>
-              <a:defRPr sz="850">
-                <a:solidFill>
-                  <a:srgbClr val="475569"/>
-                </a:solidFill>
-              </a:defRPr>
-            </a:pPr>
-            <a:r>
-              <a:t>GIS Heatmap • Scrypt/JWT RBAC • SHA-256 Signed Evidence Vault</a:t>
-            </a:r>
-          </a:p>
-        </p:txBody>
-      </p:sp>
-      <p:sp>
-        <p:nvSpPr>
-          <p:cNvPr id="17" name="Down Arrow 16"/>
-          <p:cNvSpPr/>
-          <p:nvPr/>
-        </p:nvSpPr>
-        <p:spPr>
-          <a:xfrm>
-            <a:off x="8961120" y="2212848"/>
-            <a:ext cx="228600" cy="164592"/>
-          </a:xfrm>
-          <a:prstGeom prst="downArrow">
-            <a:avLst/>
-          </a:prstGeom>
-          <a:solidFill>
-            <a:srgbClr val="CBD5E1"/>
-          </a:solidFill>
-          <a:ln>
-            <a:noFill/>
-          </a:ln>
-        </p:spPr>
-        <p:style>
-          <a:lnRef idx="1">
-            <a:schemeClr val="accent1"/>
-          </a:lnRef>
-          <a:fillRef idx="3">
-            <a:schemeClr val="accent1"/>
-          </a:fillRef>
-          <a:effectRef idx="2">
-            <a:schemeClr val="accent1"/>
-          </a:effectRef>
-          <a:fontRef idx="minor">
-            <a:schemeClr val="lt1"/>
-          </a:fontRef>
-        </p:style>
-        <p:txBody>
-          <a:bodyPr rtlCol="0" anchor="ctr"/>
-          <a:lstStyle/>
-          <a:p>
-            <a:pPr algn="ctr"/>
-          </a:p>
-        </p:txBody>
-      </p:sp>
-      <p:sp>
-        <p:nvSpPr>
-          <p:cNvPr id="18" name="Down Arrow 17"/>
-          <p:cNvSpPr/>
-          <p:nvPr/>
-        </p:nvSpPr>
-        <p:spPr>
-          <a:xfrm>
-            <a:off x="8961120" y="3035808"/>
-            <a:ext cx="228600" cy="164592"/>
-          </a:xfrm>
-          <a:prstGeom prst="downArrow">
-            <a:avLst/>
-          </a:prstGeom>
-          <a:solidFill>
-            <a:srgbClr val="CBD5E1"/>
-          </a:solidFill>
-          <a:ln>
-            <a:noFill/>
-          </a:ln>
-        </p:spPr>
-        <p:style>
-          <a:lnRef idx="1">
-            <a:schemeClr val="accent1"/>
-          </a:lnRef>
-          <a:fillRef idx="3">
-            <a:schemeClr val="accent1"/>
-          </a:fillRef>
-          <a:effectRef idx="2">
-            <a:schemeClr val="accent1"/>
-          </a:effectRef>
-          <a:fontRef idx="minor">
-            <a:schemeClr val="lt1"/>
-          </a:fontRef>
-        </p:style>
-        <p:txBody>
-          <a:bodyPr rtlCol="0" anchor="ctr"/>
-          <a:lstStyle/>
-          <a:p>
-            <a:pPr algn="ctr"/>
-          </a:p>
-        </p:txBody>
-      </p:sp>
-      <p:sp>
-        <p:nvSpPr>
-          <p:cNvPr id="19" name="Down Arrow 18"/>
-          <p:cNvSpPr/>
-          <p:nvPr/>
-        </p:nvSpPr>
-        <p:spPr>
-          <a:xfrm>
-            <a:off x="8961120" y="3858768"/>
-            <a:ext cx="228600" cy="164592"/>
-          </a:xfrm>
-          <a:prstGeom prst="downArrow">
-            <a:avLst/>
-          </a:prstGeom>
-          <a:solidFill>
-            <a:srgbClr val="CBD5E1"/>
-          </a:solidFill>
-          <a:ln>
-            <a:noFill/>
-          </a:ln>
-        </p:spPr>
-        <p:style>
-          <a:lnRef idx="1">
-            <a:schemeClr val="accent1"/>
-          </a:lnRef>
-          <a:fillRef idx="3">
-            <a:schemeClr val="accent1"/>
-          </a:fillRef>
-          <a:effectRef idx="2">
-            <a:schemeClr val="accent1"/>
-          </a:effectRef>
-          <a:fontRef idx="minor">
-            <a:schemeClr val="lt1"/>
-          </a:fontRef>
-        </p:style>
-        <p:txBody>
-          <a:bodyPr rtlCol="0" anchor="ctr"/>
-          <a:lstStyle/>
-          <a:p>
-            <a:pPr algn="ctr"/>
-          </a:p>
-        </p:txBody>
-      </p:sp>
-      <p:sp>
-        <p:nvSpPr>
-          <p:cNvPr id="20" name="Down Arrow 19"/>
-          <p:cNvSpPr/>
-          <p:nvPr/>
-        </p:nvSpPr>
-        <p:spPr>
-          <a:xfrm>
-            <a:off x="8961120" y="4681728"/>
-            <a:ext cx="228600" cy="164592"/>
-          </a:xfrm>
-          <a:prstGeom prst="downArrow">
-            <a:avLst/>
-          </a:prstGeom>
-          <a:solidFill>
-            <a:srgbClr val="CBD5E1"/>
-          </a:solidFill>
-          <a:ln>
-            <a:noFill/>
-          </a:ln>
-        </p:spPr>
-        <p:style>
-          <a:lnRef idx="1">
-            <a:schemeClr val="accent1"/>
-          </a:lnRef>
-          <a:fillRef idx="3">
-            <a:schemeClr val="accent1"/>
-          </a:fillRef>
-          <a:effectRef idx="2">
-            <a:schemeClr val="accent1"/>
-          </a:effectRef>
-          <a:fontRef idx="minor">
-            <a:schemeClr val="lt1"/>
-          </a:fontRef>
-        </p:style>
-        <p:txBody>
-          <a:bodyPr rtlCol="0" anchor="ctr"/>
-          <a:lstStyle/>
-          <a:p>
-            <a:pPr algn="ctr"/>
-          </a:p>
-        </p:txBody>
-      </p:sp>
+        </p:spPr>
+      </p:pic>
     </p:spTree>
   </p:cSld>
   <p:clrMapOvr>
@@ -5927,64 +4713,30 @@
           </a:p>
         </p:txBody>
       </p:sp>
-      <p:sp>
-        <p:nvSpPr>
-          <p:cNvPr id="6" name="Oval 5"/>
-          <p:cNvSpPr/>
+      <p:pic>
+        <p:nvPicPr>
+          <p:cNvPr id="6" name="Picture 5" descr="slide4_mindmap.png"/>
+          <p:cNvPicPr>
+            <a:picLocks noChangeAspect="1"/>
+          </p:cNvPicPr>
           <p:nvPr/>
-        </p:nvSpPr>
-        <p:spPr>
-          <a:xfrm>
-            <a:off x="5029200" y="1005840"/>
-            <a:ext cx="2103120" cy="914400"/>
-          </a:xfrm>
-          <a:prstGeom prst="ellipse">
+        </p:nvPicPr>
+        <p:blipFill>
+          <a:blip r:embed="rId3"/>
+          <a:stretch>
+            <a:fillRect/>
+          </a:stretch>
+        </p:blipFill>
+        <p:spPr>
+          <a:xfrm>
+            <a:off x="457200" y="960120"/>
+            <a:ext cx="11247120" cy="2993185"/>
+          </a:xfrm>
+          <a:prstGeom prst="rect">
             <a:avLst/>
           </a:prstGeom>
-          <a:solidFill>
-            <a:srgbClr val="FFFFFF"/>
-          </a:solidFill>
-          <a:ln w="31750">
-            <a:solidFill>
-              <a:srgbClr val="D97706"/>
-            </a:solidFill>
-          </a:ln>
-        </p:spPr>
-        <p:style>
-          <a:lnRef idx="1">
-            <a:schemeClr val="accent1"/>
-          </a:lnRef>
-          <a:fillRef idx="3">
-            <a:schemeClr val="accent1"/>
-          </a:fillRef>
-          <a:effectRef idx="2">
-            <a:schemeClr val="accent1"/>
-          </a:effectRef>
-          <a:fontRef idx="minor">
-            <a:schemeClr val="lt1"/>
-          </a:fontRef>
-        </p:style>
-        <p:txBody>
-          <a:bodyPr rtlCol="0" anchor="ctr"/>
-          <a:lstStyle/>
-          <a:p>
-            <a:pPr algn="ctr">
-              <a:defRPr b="1" sz="1400">
-                <a:solidFill>
-                  <a:srgbClr val="D97706"/>
-                </a:solidFill>
-              </a:defRPr>
-            </a:pPr>
-            <a:r>
-              <a:t>Feasibility</a:t>
-            </a:r>
-            <a:br/>
-            <a:r>
-              <a:t>&amp; Viability</a:t>
-            </a:r>
-          </a:p>
-        </p:txBody>
-      </p:sp>
+        </p:spPr>
+      </p:pic>
       <p:sp>
         <p:nvSpPr>
           <p:cNvPr id="7" name="Rounded Rectangle 6"/>
@@ -5993,600 +4745,8 @@
         </p:nvSpPr>
         <p:spPr>
           <a:xfrm>
-            <a:off x="457200" y="1097280"/>
-            <a:ext cx="4114800" cy="411480"/>
-          </a:xfrm>
-          <a:prstGeom prst="roundRect">
-            <a:avLst/>
-          </a:prstGeom>
-          <a:solidFill>
-            <a:srgbClr val="D97706"/>
-          </a:solidFill>
-          <a:ln>
-            <a:noFill/>
-          </a:ln>
-        </p:spPr>
-        <p:style>
-          <a:lnRef idx="1">
-            <a:schemeClr val="accent1"/>
-          </a:lnRef>
-          <a:fillRef idx="3">
-            <a:schemeClr val="accent1"/>
-          </a:fillRef>
-          <a:effectRef idx="2">
-            <a:schemeClr val="accent1"/>
-          </a:effectRef>
-          <a:fontRef idx="minor">
-            <a:schemeClr val="lt1"/>
-          </a:fontRef>
-        </p:style>
-        <p:txBody>
-          <a:bodyPr rtlCol="0" anchor="ctr"/>
-          <a:lstStyle/>
-          <a:p>
-            <a:pPr algn="ctr">
-              <a:defRPr b="1" sz="1100">
-                <a:solidFill>
-                  <a:srgbClr val="FFFFFF"/>
-                </a:solidFill>
-              </a:defRPr>
-            </a:pPr>
-            <a:r>
-              <a:t>Potential Challenges &amp; Risks</a:t>
-            </a:r>
-          </a:p>
-        </p:txBody>
-      </p:sp>
-      <p:sp>
-        <p:nvSpPr>
-          <p:cNvPr id="8" name="Rounded Rectangle 7"/>
-          <p:cNvSpPr/>
-          <p:nvPr/>
-        </p:nvSpPr>
-        <p:spPr>
-          <a:xfrm>
-            <a:off x="457200" y="1645920"/>
-            <a:ext cx="4114800" cy="594360"/>
-          </a:xfrm>
-          <a:prstGeom prst="roundRect">
-            <a:avLst/>
-          </a:prstGeom>
-          <a:solidFill>
-            <a:srgbClr val="FFFFFF"/>
-          </a:solidFill>
-          <a:ln w="12700">
-            <a:solidFill>
-              <a:srgbClr val="CBD5E1"/>
-            </a:solidFill>
-          </a:ln>
-        </p:spPr>
-        <p:style>
-          <a:lnRef idx="1">
-            <a:schemeClr val="accent1"/>
-          </a:lnRef>
-          <a:fillRef idx="3">
-            <a:schemeClr val="accent1"/>
-          </a:fillRef>
-          <a:effectRef idx="2">
-            <a:schemeClr val="accent1"/>
-          </a:effectRef>
-          <a:fontRef idx="minor">
-            <a:schemeClr val="lt1"/>
-          </a:fontRef>
-        </p:style>
-        <p:txBody>
-          <a:bodyPr rtlCol="0" anchor="ctr" lIns="137160"/>
-          <a:lstStyle/>
-          <a:p>
-            <a:pPr algn="ctr"/>
-            <a:r>
-              <a:rPr b="1" sz="950">
-                <a:solidFill>
-                  <a:srgbClr val="E11D48"/>
-                </a:solidFill>
-              </a:rPr>
-              <a:t>TECHNICAL: </a:t>
-            </a:r>
-            <a:r>
-              <a:rPr sz="850">
-                <a:solidFill>
-                  <a:srgbClr val="0F172A"/>
-                </a:solidFill>
-              </a:rPr>
-              <a:t>High CCTV video resolution bottlenecks rural 2G/3G bandwidth; camera blinding or angle tampering.</a:t>
-            </a:r>
-          </a:p>
-        </p:txBody>
-      </p:sp>
-      <p:sp>
-        <p:nvSpPr>
-          <p:cNvPr id="9" name="Rounded Rectangle 8"/>
-          <p:cNvSpPr/>
-          <p:nvPr/>
-        </p:nvSpPr>
-        <p:spPr>
-          <a:xfrm>
-            <a:off x="457200" y="2304288"/>
-            <a:ext cx="4114800" cy="594360"/>
-          </a:xfrm>
-          <a:prstGeom prst="roundRect">
-            <a:avLst/>
-          </a:prstGeom>
-          <a:solidFill>
-            <a:srgbClr val="FFFFFF"/>
-          </a:solidFill>
-          <a:ln w="12700">
-            <a:solidFill>
-              <a:srgbClr val="CBD5E1"/>
-            </a:solidFill>
-          </a:ln>
-        </p:spPr>
-        <p:style>
-          <a:lnRef idx="1">
-            <a:schemeClr val="accent1"/>
-          </a:lnRef>
-          <a:fillRef idx="3">
-            <a:schemeClr val="accent1"/>
-          </a:fillRef>
-          <a:effectRef idx="2">
-            <a:schemeClr val="accent1"/>
-          </a:effectRef>
-          <a:fontRef idx="minor">
-            <a:schemeClr val="lt1"/>
-          </a:fontRef>
-        </p:style>
-        <p:txBody>
-          <a:bodyPr rtlCol="0" anchor="ctr" lIns="137160"/>
-          <a:lstStyle/>
-          <a:p>
-            <a:pPr algn="ctr"/>
-            <a:r>
-              <a:rPr b="1" sz="950">
-                <a:solidFill>
-                  <a:srgbClr val="E11D48"/>
-                </a:solidFill>
-              </a:rPr>
-              <a:t>OPERATIONAL: </a:t>
-            </a:r>
-            <a:r>
-              <a:rPr sz="850">
-                <a:solidFill>
-                  <a:srgbClr val="0F172A"/>
-                </a:solidFill>
-              </a:rPr>
-              <a:t>Frequent rural electricity/broadband outages; absence of on-site IT technicians at remote ITIs.</a:t>
-            </a:r>
-          </a:p>
-        </p:txBody>
-      </p:sp>
-      <p:sp>
-        <p:nvSpPr>
-          <p:cNvPr id="10" name="Rounded Rectangle 9"/>
-          <p:cNvSpPr/>
-          <p:nvPr/>
-        </p:nvSpPr>
-        <p:spPr>
-          <a:xfrm>
-            <a:off x="457200" y="2962656"/>
-            <a:ext cx="4114800" cy="594360"/>
-          </a:xfrm>
-          <a:prstGeom prst="roundRect">
-            <a:avLst/>
-          </a:prstGeom>
-          <a:solidFill>
-            <a:srgbClr val="FFFFFF"/>
-          </a:solidFill>
-          <a:ln w="12700">
-            <a:solidFill>
-              <a:srgbClr val="CBD5E1"/>
-            </a:solidFill>
-          </a:ln>
-        </p:spPr>
-        <p:style>
-          <a:lnRef idx="1">
-            <a:schemeClr val="accent1"/>
-          </a:lnRef>
-          <a:fillRef idx="3">
-            <a:schemeClr val="accent1"/>
-          </a:fillRef>
-          <a:effectRef idx="2">
-            <a:schemeClr val="accent1"/>
-          </a:effectRef>
-          <a:fontRef idx="minor">
-            <a:schemeClr val="lt1"/>
-          </a:fontRef>
-        </p:style>
-        <p:txBody>
-          <a:bodyPr rtlCol="0" anchor="ctr" lIns="137160"/>
-          <a:lstStyle/>
-          <a:p>
-            <a:pPr algn="ctr"/>
-            <a:r>
-              <a:rPr b="1" sz="950">
-                <a:solidFill>
-                  <a:srgbClr val="E11D48"/>
-                </a:solidFill>
-              </a:rPr>
-              <a:t>FINANCIAL: </a:t>
-            </a:r>
-            <a:r>
-              <a:rPr sz="850">
-                <a:solidFill>
-                  <a:srgbClr val="0F172A"/>
-                </a:solidFill>
-              </a:rPr>
-              <a:t>Prohibitive cloud GPU inference costs; expensive hardware upgrades burdening training centres.</a:t>
-            </a:r>
-          </a:p>
-        </p:txBody>
-      </p:sp>
-      <p:sp>
-        <p:nvSpPr>
-          <p:cNvPr id="11" name="Rounded Rectangle 10"/>
-          <p:cNvSpPr/>
-          <p:nvPr/>
-        </p:nvSpPr>
-        <p:spPr>
-          <a:xfrm>
-            <a:off x="457200" y="3621024"/>
-            <a:ext cx="4114800" cy="594360"/>
-          </a:xfrm>
-          <a:prstGeom prst="roundRect">
-            <a:avLst/>
-          </a:prstGeom>
-          <a:solidFill>
-            <a:srgbClr val="FFFFFF"/>
-          </a:solidFill>
-          <a:ln w="12700">
-            <a:solidFill>
-              <a:srgbClr val="CBD5E1"/>
-            </a:solidFill>
-          </a:ln>
-        </p:spPr>
-        <p:style>
-          <a:lnRef idx="1">
-            <a:schemeClr val="accent1"/>
-          </a:lnRef>
-          <a:fillRef idx="3">
-            <a:schemeClr val="accent1"/>
-          </a:fillRef>
-          <a:effectRef idx="2">
-            <a:schemeClr val="accent1"/>
-          </a:effectRef>
-          <a:fontRef idx="minor">
-            <a:schemeClr val="lt1"/>
-          </a:fontRef>
-        </p:style>
-        <p:txBody>
-          <a:bodyPr rtlCol="0" anchor="ctr" lIns="137160"/>
-          <a:lstStyle/>
-          <a:p>
-            <a:pPr algn="ctr"/>
-            <a:r>
-              <a:rPr b="1" sz="950">
-                <a:solidFill>
-                  <a:srgbClr val="E11D48"/>
-                </a:solidFill>
-              </a:rPr>
-              <a:t>REGULATORY: </a:t>
-            </a:r>
-            <a:r>
-              <a:rPr sz="850">
-                <a:solidFill>
-                  <a:srgbClr val="0F172A"/>
-                </a:solidFill>
-              </a:rPr>
-              <a:t>Trainee biometric privacy violations and legal liabilities under India's DPDP Act 2023.</a:t>
-            </a:r>
-          </a:p>
-        </p:txBody>
-      </p:sp>
-      <p:sp>
-        <p:nvSpPr>
-          <p:cNvPr id="12" name="Rounded Rectangle 11"/>
-          <p:cNvSpPr/>
-          <p:nvPr/>
-        </p:nvSpPr>
-        <p:spPr>
-          <a:xfrm>
-            <a:off x="7589520" y="1097280"/>
-            <a:ext cx="4114800" cy="411480"/>
-          </a:xfrm>
-          <a:prstGeom prst="roundRect">
-            <a:avLst/>
-          </a:prstGeom>
-          <a:solidFill>
-            <a:srgbClr val="10B981"/>
-          </a:solidFill>
-          <a:ln>
-            <a:noFill/>
-          </a:ln>
-        </p:spPr>
-        <p:style>
-          <a:lnRef idx="1">
-            <a:schemeClr val="accent1"/>
-          </a:lnRef>
-          <a:fillRef idx="3">
-            <a:schemeClr val="accent1"/>
-          </a:fillRef>
-          <a:effectRef idx="2">
-            <a:schemeClr val="accent1"/>
-          </a:effectRef>
-          <a:fontRef idx="minor">
-            <a:schemeClr val="lt1"/>
-          </a:fontRef>
-        </p:style>
-        <p:txBody>
-          <a:bodyPr rtlCol="0" anchor="ctr"/>
-          <a:lstStyle/>
-          <a:p>
-            <a:pPr algn="ctr">
-              <a:defRPr b="1" sz="1100">
-                <a:solidFill>
-                  <a:srgbClr val="FFFFFF"/>
-                </a:solidFill>
-              </a:defRPr>
-            </a:pPr>
-            <a:r>
-              <a:t>Strategies for Overcoming Challenges</a:t>
-            </a:r>
-          </a:p>
-        </p:txBody>
-      </p:sp>
-      <p:sp>
-        <p:nvSpPr>
-          <p:cNvPr id="13" name="Rounded Rectangle 12"/>
-          <p:cNvSpPr/>
-          <p:nvPr/>
-        </p:nvSpPr>
-        <p:spPr>
-          <a:xfrm>
-            <a:off x="7589520" y="1645920"/>
-            <a:ext cx="4114800" cy="594360"/>
-          </a:xfrm>
-          <a:prstGeom prst="roundRect">
-            <a:avLst/>
-          </a:prstGeom>
-          <a:solidFill>
-            <a:srgbClr val="FFFFFF"/>
-          </a:solidFill>
-          <a:ln w="12700">
-            <a:solidFill>
-              <a:srgbClr val="CBD5E1"/>
-            </a:solidFill>
-          </a:ln>
-        </p:spPr>
-        <p:style>
-          <a:lnRef idx="1">
-            <a:schemeClr val="accent1"/>
-          </a:lnRef>
-          <a:fillRef idx="3">
-            <a:schemeClr val="accent1"/>
-          </a:fillRef>
-          <a:effectRef idx="2">
-            <a:schemeClr val="accent1"/>
-          </a:effectRef>
-          <a:fontRef idx="minor">
-            <a:schemeClr val="lt1"/>
-          </a:fontRef>
-        </p:style>
-        <p:txBody>
-          <a:bodyPr rtlCol="0" anchor="ctr" lIns="137160"/>
-          <a:lstStyle/>
-          <a:p>
-            <a:pPr algn="ctr"/>
-            <a:r>
-              <a:rPr b="1" sz="950">
-                <a:solidFill>
-                  <a:srgbClr val="10B981"/>
-                </a:solidFill>
-              </a:rPr>
-              <a:t>TECHNICAL: </a:t>
-            </a:r>
-            <a:r>
-              <a:rPr sz="850">
-                <a:solidFill>
-                  <a:srgbClr val="0F172A"/>
-                </a:solidFill>
-              </a:rPr>
-              <a:t>Edge-native inference pushes tiny 2 KB JSON packets (99.4% saved); anti-tamper AI alerts angle tilt.</a:t>
-            </a:r>
-          </a:p>
-        </p:txBody>
-      </p:sp>
-      <p:sp>
-        <p:nvSpPr>
-          <p:cNvPr id="14" name="Rounded Rectangle 13"/>
-          <p:cNvSpPr/>
-          <p:nvPr/>
-        </p:nvSpPr>
-        <p:spPr>
-          <a:xfrm>
-            <a:off x="7589520" y="2304288"/>
-            <a:ext cx="4114800" cy="594360"/>
-          </a:xfrm>
-          <a:prstGeom prst="roundRect">
-            <a:avLst/>
-          </a:prstGeom>
-          <a:solidFill>
-            <a:srgbClr val="FFFFFF"/>
-          </a:solidFill>
-          <a:ln w="12700">
-            <a:solidFill>
-              <a:srgbClr val="CBD5E1"/>
-            </a:solidFill>
-          </a:ln>
-        </p:spPr>
-        <p:style>
-          <a:lnRef idx="1">
-            <a:schemeClr val="accent1"/>
-          </a:lnRef>
-          <a:fillRef idx="3">
-            <a:schemeClr val="accent1"/>
-          </a:fillRef>
-          <a:effectRef idx="2">
-            <a:schemeClr val="accent1"/>
-          </a:effectRef>
-          <a:fontRef idx="minor">
-            <a:schemeClr val="lt1"/>
-          </a:fontRef>
-        </p:style>
-        <p:txBody>
-          <a:bodyPr rtlCol="0" anchor="ctr" lIns="137160"/>
-          <a:lstStyle/>
-          <a:p>
-            <a:pPr algn="ctr"/>
-            <a:r>
-              <a:rPr b="1" sz="950">
-                <a:solidFill>
-                  <a:srgbClr val="10B981"/>
-                </a:solidFill>
-              </a:rPr>
-              <a:t>OPERATIONAL: </a:t>
-            </a:r>
-            <a:r>
-              <a:rPr sz="850">
-                <a:solidFill>
-                  <a:srgbClr val="0F172A"/>
-                </a:solidFill>
-              </a:rPr>
-              <a:t>72-hour SQLite store-and-forward caching; zero-touch plug-and-play gateway auto-reconnects.</a:t>
-            </a:r>
-          </a:p>
-        </p:txBody>
-      </p:sp>
-      <p:sp>
-        <p:nvSpPr>
-          <p:cNvPr id="15" name="Rounded Rectangle 14"/>
-          <p:cNvSpPr/>
-          <p:nvPr/>
-        </p:nvSpPr>
-        <p:spPr>
-          <a:xfrm>
-            <a:off x="7589520" y="2962656"/>
-            <a:ext cx="4114800" cy="594360"/>
-          </a:xfrm>
-          <a:prstGeom prst="roundRect">
-            <a:avLst/>
-          </a:prstGeom>
-          <a:solidFill>
-            <a:srgbClr val="FFFFFF"/>
-          </a:solidFill>
-          <a:ln w="12700">
-            <a:solidFill>
-              <a:srgbClr val="CBD5E1"/>
-            </a:solidFill>
-          </a:ln>
-        </p:spPr>
-        <p:style>
-          <a:lnRef idx="1">
-            <a:schemeClr val="accent1"/>
-          </a:lnRef>
-          <a:fillRef idx="3">
-            <a:schemeClr val="accent1"/>
-          </a:fillRef>
-          <a:effectRef idx="2">
-            <a:schemeClr val="accent1"/>
-          </a:effectRef>
-          <a:fontRef idx="minor">
-            <a:schemeClr val="lt1"/>
-          </a:fontRef>
-        </p:style>
-        <p:txBody>
-          <a:bodyPr rtlCol="0" anchor="ctr" lIns="137160"/>
-          <a:lstStyle/>
-          <a:p>
-            <a:pPr algn="ctr"/>
-            <a:r>
-              <a:rPr b="1" sz="950">
-                <a:solidFill>
-                  <a:srgbClr val="10B981"/>
-                </a:solidFill>
-              </a:rPr>
-              <a:t>FINANCIAL: </a:t>
-            </a:r>
-            <a:r>
-              <a:rPr sz="850">
-                <a:solidFill>
-                  <a:srgbClr val="0F172A"/>
-                </a:solidFill>
-              </a:rPr>
-              <a:t>Quantized INT8 models execute on sub-₹7k Mini-PCs; cloud compute drops to &lt;₹80/mo per centre.</a:t>
-            </a:r>
-          </a:p>
-        </p:txBody>
-      </p:sp>
-      <p:sp>
-        <p:nvSpPr>
-          <p:cNvPr id="16" name="Rounded Rectangle 15"/>
-          <p:cNvSpPr/>
-          <p:nvPr/>
-        </p:nvSpPr>
-        <p:spPr>
-          <a:xfrm>
-            <a:off x="7589520" y="3621024"/>
-            <a:ext cx="4114800" cy="594360"/>
-          </a:xfrm>
-          <a:prstGeom prst="roundRect">
-            <a:avLst/>
-          </a:prstGeom>
-          <a:solidFill>
-            <a:srgbClr val="FFFFFF"/>
-          </a:solidFill>
-          <a:ln w="12700">
-            <a:solidFill>
-              <a:srgbClr val="CBD5E1"/>
-            </a:solidFill>
-          </a:ln>
-        </p:spPr>
-        <p:style>
-          <a:lnRef idx="1">
-            <a:schemeClr val="accent1"/>
-          </a:lnRef>
-          <a:fillRef idx="3">
-            <a:schemeClr val="accent1"/>
-          </a:fillRef>
-          <a:effectRef idx="2">
-            <a:schemeClr val="accent1"/>
-          </a:effectRef>
-          <a:fontRef idx="minor">
-            <a:schemeClr val="lt1"/>
-          </a:fontRef>
-        </p:style>
-        <p:txBody>
-          <a:bodyPr rtlCol="0" anchor="ctr" lIns="137160"/>
-          <a:lstStyle/>
-          <a:p>
-            <a:pPr algn="ctr"/>
-            <a:r>
-              <a:rPr b="1" sz="950">
-                <a:solidFill>
-                  <a:srgbClr val="10B981"/>
-                </a:solidFill>
-              </a:rPr>
-              <a:t>REGULATORY: </a:t>
-            </a:r>
-            <a:r>
-              <a:rPr sz="850">
-                <a:solidFill>
-                  <a:srgbClr val="0F172A"/>
-                </a:solidFill>
-              </a:rPr>
-              <a:t>Irreversible edge face-blurring directly in volatile memory; zero biometric vectors stored.</a:t>
-            </a:r>
-          </a:p>
-        </p:txBody>
-      </p:sp>
-      <p:sp>
-        <p:nvSpPr>
-          <p:cNvPr id="17" name="Rounded Rectangle 16"/>
-          <p:cNvSpPr/>
-          <p:nvPr/>
-        </p:nvSpPr>
-        <p:spPr>
-          <a:xfrm>
-            <a:off x="457200" y="4389120"/>
-            <a:ext cx="2743200" cy="1691640"/>
+            <a:off x="457200" y="4160520"/>
+            <a:ext cx="2697480" cy="1874519"/>
           </a:xfrm>
           <a:prstGeom prst="roundRect">
             <a:avLst/>
@@ -6619,7 +4779,7 @@
           <a:lstStyle/>
           <a:p>
             <a:pPr algn="ctr">
-              <a:defRPr b="1" sz="1000">
+              <a:defRPr b="1" sz="950">
                 <a:solidFill>
                   <a:srgbClr val="0284C7"/>
                 </a:solidFill>
@@ -6631,7 +4791,7 @@
           </a:p>
           <a:p>
             <a:pPr>
-              <a:defRPr sz="850">
+              <a:defRPr sz="819">
                 <a:solidFill>
                   <a:srgbClr val="0F172A"/>
                 </a:solidFill>
@@ -6643,7 +4803,7 @@
           </a:p>
           <a:p>
             <a:pPr>
-              <a:defRPr sz="850">
+              <a:defRPr sz="819">
                 <a:solidFill>
                   <a:srgbClr val="0F172A"/>
                 </a:solidFill>
@@ -6655,7 +4815,7 @@
           </a:p>
           <a:p>
             <a:pPr>
-              <a:defRPr sz="850">
+              <a:defRPr sz="819">
                 <a:solidFill>
                   <a:srgbClr val="0F172A"/>
                 </a:solidFill>
@@ -6667,7 +4827,7 @@
           </a:p>
           <a:p>
             <a:pPr>
-              <a:defRPr sz="850">
+              <a:defRPr sz="819">
                 <a:solidFill>
                   <a:srgbClr val="0F172A"/>
                 </a:solidFill>
@@ -6681,14 +4841,14 @@
       </p:sp>
       <p:sp>
         <p:nvSpPr>
-          <p:cNvPr id="18" name="Rounded Rectangle 17"/>
+          <p:cNvPr id="8" name="Rounded Rectangle 7"/>
           <p:cNvSpPr/>
           <p:nvPr/>
         </p:nvSpPr>
         <p:spPr>
           <a:xfrm>
-            <a:off x="3291840" y="4389120"/>
-            <a:ext cx="2743200" cy="1691640"/>
+            <a:off x="3291840" y="4160520"/>
+            <a:ext cx="2697480" cy="1874519"/>
           </a:xfrm>
           <a:prstGeom prst="roundRect">
             <a:avLst/>
@@ -6721,7 +4881,7 @@
           <a:lstStyle/>
           <a:p>
             <a:pPr algn="ctr">
-              <a:defRPr b="1" sz="1000">
+              <a:defRPr b="1" sz="950">
                 <a:solidFill>
                   <a:srgbClr val="007E8A"/>
                 </a:solidFill>
@@ -6733,7 +4893,7 @@
           </a:p>
           <a:p>
             <a:pPr>
-              <a:defRPr sz="850">
+              <a:defRPr sz="819">
                 <a:solidFill>
                   <a:srgbClr val="0F172A"/>
                 </a:solidFill>
@@ -6745,7 +4905,7 @@
           </a:p>
           <a:p>
             <a:pPr>
-              <a:defRPr sz="850">
+              <a:defRPr sz="819">
                 <a:solidFill>
                   <a:srgbClr val="0F172A"/>
                 </a:solidFill>
@@ -6757,7 +4917,7 @@
           </a:p>
           <a:p>
             <a:pPr>
-              <a:defRPr sz="850">
+              <a:defRPr sz="819">
                 <a:solidFill>
                   <a:srgbClr val="0F172A"/>
                 </a:solidFill>
@@ -6769,7 +4929,7 @@
           </a:p>
           <a:p>
             <a:pPr>
-              <a:defRPr sz="850">
+              <a:defRPr sz="819">
                 <a:solidFill>
                   <a:srgbClr val="0F172A"/>
                 </a:solidFill>
@@ -6783,14 +4943,14 @@
       </p:sp>
       <p:sp>
         <p:nvSpPr>
-          <p:cNvPr id="19" name="Rounded Rectangle 18"/>
+          <p:cNvPr id="9" name="Rounded Rectangle 8"/>
           <p:cNvSpPr/>
           <p:nvPr/>
         </p:nvSpPr>
         <p:spPr>
           <a:xfrm>
-            <a:off x="6126480" y="4389120"/>
-            <a:ext cx="2743200" cy="1691640"/>
+            <a:off x="6126480" y="4160520"/>
+            <a:ext cx="2697480" cy="1874519"/>
           </a:xfrm>
           <a:prstGeom prst="roundRect">
             <a:avLst/>
@@ -6823,7 +4983,7 @@
           <a:lstStyle/>
           <a:p>
             <a:pPr algn="ctr">
-              <a:defRPr b="1" sz="1000">
+              <a:defRPr b="1" sz="950">
                 <a:solidFill>
                   <a:srgbClr val="D97706"/>
                 </a:solidFill>
@@ -6835,7 +4995,7 @@
           </a:p>
           <a:p>
             <a:pPr>
-              <a:defRPr sz="850">
+              <a:defRPr sz="819">
                 <a:solidFill>
                   <a:srgbClr val="0F172A"/>
                 </a:solidFill>
@@ -6847,7 +5007,7 @@
           </a:p>
           <a:p>
             <a:pPr>
-              <a:defRPr sz="850">
+              <a:defRPr sz="819">
                 <a:solidFill>
                   <a:srgbClr val="0F172A"/>
                 </a:solidFill>
@@ -6859,7 +5019,7 @@
           </a:p>
           <a:p>
             <a:pPr>
-              <a:defRPr sz="850">
+              <a:defRPr sz="819">
                 <a:solidFill>
                   <a:srgbClr val="0F172A"/>
                 </a:solidFill>
@@ -6871,7 +5031,7 @@
           </a:p>
           <a:p>
             <a:pPr>
-              <a:defRPr sz="850">
+              <a:defRPr sz="819">
                 <a:solidFill>
                   <a:srgbClr val="0F172A"/>
                 </a:solidFill>
@@ -6885,14 +5045,14 @@
       </p:sp>
       <p:sp>
         <p:nvSpPr>
-          <p:cNvPr id="20" name="Rounded Rectangle 19"/>
+          <p:cNvPr id="10" name="Rounded Rectangle 9"/>
           <p:cNvSpPr/>
           <p:nvPr/>
         </p:nvSpPr>
         <p:spPr>
           <a:xfrm>
-            <a:off x="8961120" y="4389120"/>
-            <a:ext cx="2743200" cy="1691640"/>
+            <a:off x="8961120" y="4160520"/>
+            <a:ext cx="2697480" cy="1874519"/>
           </a:xfrm>
           <a:prstGeom prst="roundRect">
             <a:avLst/>
@@ -6925,7 +5085,7 @@
           <a:lstStyle/>
           <a:p>
             <a:pPr algn="ctr">
-              <a:defRPr b="1" sz="1000">
+              <a:defRPr b="1" sz="950">
                 <a:solidFill>
                   <a:srgbClr val="10B981"/>
                 </a:solidFill>
@@ -6937,7 +5097,7 @@
           </a:p>
           <a:p>
             <a:pPr>
-              <a:defRPr sz="850">
+              <a:defRPr sz="819">
                 <a:solidFill>
                   <a:srgbClr val="0F172A"/>
                 </a:solidFill>
@@ -6949,7 +5109,7 @@
           </a:p>
           <a:p>
             <a:pPr>
-              <a:defRPr sz="850">
+              <a:defRPr sz="819">
                 <a:solidFill>
                   <a:srgbClr val="0F172A"/>
                 </a:solidFill>
@@ -6961,7 +5121,7 @@
           </a:p>
           <a:p>
             <a:pPr>
-              <a:defRPr sz="850">
+              <a:defRPr sz="819">
                 <a:solidFill>
                   <a:srgbClr val="0F172A"/>
                 </a:solidFill>
@@ -6973,7 +5133,7 @@
           </a:p>
           <a:p>
             <a:pPr>
-              <a:defRPr sz="850">
+              <a:defRPr sz="819">
                 <a:solidFill>
                   <a:srgbClr val="0F172A"/>
                 </a:solidFill>
@@ -6987,13 +5147,13 @@
       </p:sp>
       <p:sp>
         <p:nvSpPr>
-          <p:cNvPr id="21" name="TextBox 20"/>
+          <p:cNvPr id="11" name="TextBox 10"/>
           <p:cNvSpPr txBox="1"/>
           <p:nvPr/>
         </p:nvSpPr>
         <p:spPr>
           <a:xfrm>
-            <a:off x="2743200" y="6126480"/>
+            <a:off x="2743200" y="6172200"/>
             <a:ext cx="6675120" cy="320040"/>
           </a:xfrm>
           <a:prstGeom prst="rect">
@@ -7008,7 +5168,7 @@
           <a:lstStyle/>
           <a:p>
             <a:pPr algn="ctr">
-              <a:defRPr b="1" sz="1000">
+              <a:defRPr b="1" sz="950">
                 <a:solidFill>
                   <a:srgbClr val="0284C7"/>
                 </a:solidFill>
@@ -7212,7 +5372,7 @@
           <a:lstStyle/>
           <a:p>
             <a:pPr>
-              <a:defRPr b="1" sz="1500">
+              <a:defRPr b="1" sz="1400">
                 <a:solidFill>
                   <a:srgbClr val="007E8A"/>
                 </a:solidFill>
@@ -7941,7 +6101,7 @@
         <p:spPr>
           <a:xfrm>
             <a:off x="6217920" y="960120"/>
-            <a:ext cx="5486400" cy="411480"/>
+            <a:ext cx="4114800" cy="411480"/>
           </a:xfrm>
           <a:prstGeom prst="rect">
             <a:avLst/>
@@ -7949,13 +6109,13 @@
           <a:noFill/>
         </p:spPr>
         <p:txBody>
-          <a:bodyPr wrap="none">
+          <a:bodyPr wrap="none" lIns="0" tIns="0">
             <a:spAutoFit/>
           </a:bodyPr>
           <a:lstStyle/>
           <a:p>
             <a:pPr>
-              <a:defRPr b="1" sz="1500">
+              <a:defRPr b="1" sz="1350">
                 <a:solidFill>
                   <a:srgbClr val="007E8A"/>
                 </a:solidFill>
@@ -7967,546 +6127,30 @@
           </a:p>
         </p:txBody>
       </p:sp>
-      <p:sp>
-        <p:nvSpPr>
-          <p:cNvPr id="20" name="Rounded Rectangle 19"/>
-          <p:cNvSpPr/>
+      <p:pic>
+        <p:nvPicPr>
+          <p:cNvPr id="20" name="Picture 19" descr="slide5_roadmap.png"/>
+          <p:cNvPicPr>
+            <a:picLocks noChangeAspect="1"/>
+          </p:cNvPicPr>
           <p:nvPr/>
-        </p:nvSpPr>
-        <p:spPr>
-          <a:xfrm>
-            <a:off x="6217920" y="1554480"/>
-            <a:ext cx="1783080" cy="1920240"/>
-          </a:xfrm>
-          <a:prstGeom prst="roundRect">
+        </p:nvPicPr>
+        <p:blipFill>
+          <a:blip r:embed="rId3"/>
+          <a:stretch>
+            <a:fillRect/>
+          </a:stretch>
+        </p:blipFill>
+        <p:spPr>
+          <a:xfrm>
+            <a:off x="6217920" y="1371600"/>
+            <a:ext cx="5303520" cy="3267825"/>
+          </a:xfrm>
+          <a:prstGeom prst="rect">
             <a:avLst/>
           </a:prstGeom>
-          <a:solidFill>
-            <a:srgbClr val="FFFFFF"/>
-          </a:solidFill>
-          <a:ln w="19050">
-            <a:solidFill>
-              <a:srgbClr val="1B365D"/>
-            </a:solidFill>
-          </a:ln>
-        </p:spPr>
-        <p:style>
-          <a:lnRef idx="1">
-            <a:schemeClr val="accent1"/>
-          </a:lnRef>
-          <a:fillRef idx="3">
-            <a:schemeClr val="accent1"/>
-          </a:fillRef>
-          <a:effectRef idx="2">
-            <a:schemeClr val="accent1"/>
-          </a:effectRef>
-          <a:fontRef idx="minor">
-            <a:schemeClr val="lt1"/>
-          </a:fontRef>
-        </p:style>
-        <p:txBody>
-          <a:bodyPr rtlCol="0" anchor="ctr" lIns="109728" tIns="109728"/>
-          <a:lstStyle/>
-          <a:p>
-            <a:pPr algn="ctr">
-              <a:defRPr b="1" sz="900">
-                <a:solidFill>
-                  <a:srgbClr val="1B365D"/>
-                </a:solidFill>
-              </a:defRPr>
-            </a:pPr>
-            <a:r>
-              <a:t>Sprint 1: CORE EDGE AI</a:t>
-            </a:r>
-          </a:p>
-          <a:p>
-            <a:pPr>
-              <a:defRPr sz="750">
-                <a:solidFill>
-                  <a:srgbClr val="0F172A"/>
-                </a:solidFill>
-              </a:defRPr>
-            </a:pPr>
-            <a:r>
-              <a:t>• Real-time webcam &amp; RTSP ingest</a:t>
-            </a:r>
-          </a:p>
-          <a:p>
-            <a:pPr>
-              <a:defRPr sz="750">
-                <a:solidFill>
-                  <a:srgbClr val="0F172A"/>
-                </a:solidFill>
-              </a:defRPr>
-            </a:pPr>
-            <a:r>
-              <a:t>• 50 FPS face de-identification</a:t>
-            </a:r>
-          </a:p>
-          <a:p>
-            <a:pPr>
-              <a:defRPr sz="750">
-                <a:solidFill>
-                  <a:srgbClr val="0F172A"/>
-                </a:solidFill>
-              </a:defRPr>
-            </a:pPr>
-            <a:r>
-              <a:t>• Volatile RAM DPDP shield</a:t>
-            </a:r>
-          </a:p>
-        </p:txBody>
-      </p:sp>
-      <p:sp>
-        <p:nvSpPr>
-          <p:cNvPr id="21" name="Rounded Rectangle 20"/>
-          <p:cNvSpPr/>
-          <p:nvPr/>
-        </p:nvSpPr>
-        <p:spPr>
-          <a:xfrm>
-            <a:off x="8138160" y="1554480"/>
-            <a:ext cx="1783080" cy="1920240"/>
-          </a:xfrm>
-          <a:prstGeom prst="roundRect">
-            <a:avLst/>
-          </a:prstGeom>
-          <a:solidFill>
-            <a:srgbClr val="FFFFFF"/>
-          </a:solidFill>
-          <a:ln w="19050">
-            <a:solidFill>
-              <a:srgbClr val="007E8A"/>
-            </a:solidFill>
-          </a:ln>
-        </p:spPr>
-        <p:style>
-          <a:lnRef idx="1">
-            <a:schemeClr val="accent1"/>
-          </a:lnRef>
-          <a:fillRef idx="3">
-            <a:schemeClr val="accent1"/>
-          </a:fillRef>
-          <a:effectRef idx="2">
-            <a:schemeClr val="accent1"/>
-          </a:effectRef>
-          <a:fontRef idx="minor">
-            <a:schemeClr val="lt1"/>
-          </a:fontRef>
-        </p:style>
-        <p:txBody>
-          <a:bodyPr rtlCol="0" anchor="ctr" lIns="109728" tIns="109728"/>
-          <a:lstStyle/>
-          <a:p>
-            <a:pPr algn="ctr">
-              <a:defRPr b="1" sz="900">
-                <a:solidFill>
-                  <a:srgbClr val="007E8A"/>
-                </a:solidFill>
-              </a:defRPr>
-            </a:pPr>
-            <a:r>
-              <a:t>Sprint 2: HEADCOUNT &amp; ASSETS</a:t>
-            </a:r>
-          </a:p>
-          <a:p>
-            <a:pPr>
-              <a:defRPr sz="750">
-                <a:solidFill>
-                  <a:srgbClr val="0F172A"/>
-                </a:solidFill>
-              </a:defRPr>
-            </a:pPr>
-            <a:r>
-              <a:t>• YOLOv8 spatial headcount</a:t>
-            </a:r>
-          </a:p>
-          <a:p>
-            <a:pPr>
-              <a:defRPr sz="750">
-                <a:solidFill>
-                  <a:srgbClr val="0F172A"/>
-                </a:solidFill>
-              </a:defRPr>
-            </a:pPr>
-            <a:r>
-              <a:t>• Sanctioned tool detection</a:t>
-            </a:r>
-          </a:p>
-          <a:p>
-            <a:pPr>
-              <a:defRPr sz="750">
-                <a:solidFill>
-                  <a:srgbClr val="0F172A"/>
-                </a:solidFill>
-              </a:defRPr>
-            </a:pPr>
-            <a:r>
-              <a:t>• Temporal 5-min smoothing</a:t>
-            </a:r>
-          </a:p>
-        </p:txBody>
-      </p:sp>
-      <p:sp>
-        <p:nvSpPr>
-          <p:cNvPr id="22" name="Rounded Rectangle 21"/>
-          <p:cNvSpPr/>
-          <p:nvPr/>
-        </p:nvSpPr>
-        <p:spPr>
-          <a:xfrm>
-            <a:off x="10058400" y="1554480"/>
-            <a:ext cx="1783080" cy="1920240"/>
-          </a:xfrm>
-          <a:prstGeom prst="roundRect">
-            <a:avLst/>
-          </a:prstGeom>
-          <a:solidFill>
-            <a:srgbClr val="FFFFFF"/>
-          </a:solidFill>
-          <a:ln w="19050">
-            <a:solidFill>
-              <a:srgbClr val="D97706"/>
-            </a:solidFill>
-          </a:ln>
-        </p:spPr>
-        <p:style>
-          <a:lnRef idx="1">
-            <a:schemeClr val="accent1"/>
-          </a:lnRef>
-          <a:fillRef idx="3">
-            <a:schemeClr val="accent1"/>
-          </a:fillRef>
-          <a:effectRef idx="2">
-            <a:schemeClr val="accent1"/>
-          </a:effectRef>
-          <a:fontRef idx="minor">
-            <a:schemeClr val="lt1"/>
-          </a:fontRef>
-        </p:style>
-        <p:txBody>
-          <a:bodyPr rtlCol="0" anchor="ctr" lIns="109728" tIns="109728"/>
-          <a:lstStyle/>
-          <a:p>
-            <a:pPr algn="ctr">
-              <a:defRPr b="1" sz="900">
-                <a:solidFill>
-                  <a:srgbClr val="D97706"/>
-                </a:solidFill>
-              </a:defRPr>
-            </a:pPr>
-            <a:r>
-              <a:t>Sprint 3: OFFLINE TELEMETRY</a:t>
-            </a:r>
-          </a:p>
-          <a:p>
-            <a:pPr>
-              <a:defRPr sz="750">
-                <a:solidFill>
-                  <a:srgbClr val="0F172A"/>
-                </a:solidFill>
-              </a:defRPr>
-            </a:pPr>
-            <a:r>
-              <a:t>• 72-hr SQLite store &amp; forward</a:t>
-            </a:r>
-          </a:p>
-          <a:p>
-            <a:pPr>
-              <a:defRPr sz="750">
-                <a:solidFill>
-                  <a:srgbClr val="0F172A"/>
-                </a:solidFill>
-              </a:defRPr>
-            </a:pPr>
-            <a:r>
-              <a:t>• 2-5 KB JSON sync engine</a:t>
-            </a:r>
-          </a:p>
-          <a:p>
-            <a:pPr>
-              <a:defRPr sz="750">
-                <a:solidFill>
-                  <a:srgbClr val="0F172A"/>
-                </a:solidFill>
-              </a:defRPr>
-            </a:pPr>
-            <a:r>
-              <a:t>• Offline reconnect recovery</a:t>
-            </a:r>
-          </a:p>
-        </p:txBody>
-      </p:sp>
-      <p:sp>
-        <p:nvSpPr>
-          <p:cNvPr id="23" name="Rounded Rectangle 22"/>
-          <p:cNvSpPr/>
-          <p:nvPr/>
-        </p:nvSpPr>
-        <p:spPr>
-          <a:xfrm>
-            <a:off x="6217920" y="3840480"/>
-            <a:ext cx="1783080" cy="1920240"/>
-          </a:xfrm>
-          <a:prstGeom prst="roundRect">
-            <a:avLst/>
-          </a:prstGeom>
-          <a:solidFill>
-            <a:srgbClr val="FFFFFF"/>
-          </a:solidFill>
-          <a:ln w="19050">
-            <a:solidFill>
-              <a:srgbClr val="064E3B"/>
-            </a:solidFill>
-          </a:ln>
-        </p:spPr>
-        <p:style>
-          <a:lnRef idx="1">
-            <a:schemeClr val="accent1"/>
-          </a:lnRef>
-          <a:fillRef idx="3">
-            <a:schemeClr val="accent1"/>
-          </a:fillRef>
-          <a:effectRef idx="2">
-            <a:schemeClr val="accent1"/>
-          </a:effectRef>
-          <a:fontRef idx="minor">
-            <a:schemeClr val="lt1"/>
-          </a:fontRef>
-        </p:style>
-        <p:txBody>
-          <a:bodyPr rtlCol="0" anchor="ctr" lIns="109728" tIns="109728"/>
-          <a:lstStyle/>
-          <a:p>
-            <a:pPr algn="ctr">
-              <a:defRPr b="1" sz="900">
-                <a:solidFill>
-                  <a:srgbClr val="064E3B"/>
-                </a:solidFill>
-              </a:defRPr>
-            </a:pPr>
-            <a:r>
-              <a:t>Sprint 6: NATIONAL ROLLOUT</a:t>
-            </a:r>
-          </a:p>
-          <a:p>
-            <a:pPr>
-              <a:defRPr sz="750">
-                <a:solidFill>
-                  <a:srgbClr val="0F172A"/>
-                </a:solidFill>
-              </a:defRPr>
-            </a:pPr>
-            <a:r>
-              <a:t>• 15,000+ vocational centres</a:t>
-            </a:r>
-          </a:p>
-          <a:p>
-            <a:pPr>
-              <a:defRPr sz="750">
-                <a:solidFill>
-                  <a:srgbClr val="0F172A"/>
-                </a:solidFill>
-              </a:defRPr>
-            </a:pPr>
-            <a:r>
-              <a:t>• AI attendance automated audits</a:t>
-            </a:r>
-          </a:p>
-          <a:p>
-            <a:pPr>
-              <a:defRPr sz="750">
-                <a:solidFill>
-                  <a:srgbClr val="0F172A"/>
-                </a:solidFill>
-              </a:defRPr>
-            </a:pPr>
-            <a:r>
-              <a:t>• Direct Benefit Transfer sync</a:t>
-            </a:r>
-          </a:p>
-        </p:txBody>
-      </p:sp>
-      <p:sp>
-        <p:nvSpPr>
-          <p:cNvPr id="24" name="Rounded Rectangle 23"/>
-          <p:cNvSpPr/>
-          <p:nvPr/>
-        </p:nvSpPr>
-        <p:spPr>
-          <a:xfrm>
-            <a:off x="8138160" y="3840480"/>
-            <a:ext cx="1783080" cy="1920240"/>
-          </a:xfrm>
-          <a:prstGeom prst="roundRect">
-            <a:avLst/>
-          </a:prstGeom>
-          <a:solidFill>
-            <a:srgbClr val="FFFFFF"/>
-          </a:solidFill>
-          <a:ln w="19050">
-            <a:solidFill>
-              <a:srgbClr val="0284C7"/>
-            </a:solidFill>
-          </a:ln>
-        </p:spPr>
-        <p:style>
-          <a:lnRef idx="1">
-            <a:schemeClr val="accent1"/>
-          </a:lnRef>
-          <a:fillRef idx="3">
-            <a:schemeClr val="accent1"/>
-          </a:fillRef>
-          <a:effectRef idx="2">
-            <a:schemeClr val="accent1"/>
-          </a:effectRef>
-          <a:fontRef idx="minor">
-            <a:schemeClr val="lt1"/>
-          </a:fontRef>
-        </p:style>
-        <p:txBody>
-          <a:bodyPr rtlCol="0" anchor="ctr" lIns="109728" tIns="109728"/>
-          <a:lstStyle/>
-          <a:p>
-            <a:pPr algn="ctr">
-              <a:defRPr b="1" sz="900">
-                <a:solidFill>
-                  <a:srgbClr val="0284C7"/>
-                </a:solidFill>
-              </a:defRPr>
-            </a:pPr>
-            <a:r>
-              <a:t>Sprint 5: MSDE GIS PORTAL</a:t>
-            </a:r>
-          </a:p>
-          <a:p>
-            <a:pPr>
-              <a:defRPr sz="750">
-                <a:solidFill>
-                  <a:srgbClr val="0F172A"/>
-                </a:solidFill>
-              </a:defRPr>
-            </a:pPr>
-            <a:r>
-              <a:t>• Interactive national map</a:t>
-            </a:r>
-          </a:p>
-          <a:p>
-            <a:pPr>
-              <a:defRPr sz="750">
-                <a:solidFill>
-                  <a:srgbClr val="0F172A"/>
-                </a:solidFill>
-              </a:defRPr>
-            </a:pPr>
-            <a:r>
-              <a:t>• Real-time discrepancy alert</a:t>
-            </a:r>
-          </a:p>
-          <a:p>
-            <a:pPr>
-              <a:defRPr sz="750">
-                <a:solidFill>
-                  <a:srgbClr val="0F172A"/>
-                </a:solidFill>
-              </a:defRPr>
-            </a:pPr>
-            <a:r>
-              <a:t>• Scrypt/JWT tamper security</a:t>
-            </a:r>
-          </a:p>
-        </p:txBody>
-      </p:sp>
-      <p:sp>
-        <p:nvSpPr>
-          <p:cNvPr id="25" name="Rounded Rectangle 24"/>
-          <p:cNvSpPr/>
-          <p:nvPr/>
-        </p:nvSpPr>
-        <p:spPr>
-          <a:xfrm>
-            <a:off x="10058400" y="3840480"/>
-            <a:ext cx="1783080" cy="1920240"/>
-          </a:xfrm>
-          <a:prstGeom prst="roundRect">
-            <a:avLst/>
-          </a:prstGeom>
-          <a:solidFill>
-            <a:srgbClr val="FFFFFF"/>
-          </a:solidFill>
-          <a:ln w="19050">
-            <a:solidFill>
-              <a:srgbClr val="10B981"/>
-            </a:solidFill>
-          </a:ln>
-        </p:spPr>
-        <p:style>
-          <a:lnRef idx="1">
-            <a:schemeClr val="accent1"/>
-          </a:lnRef>
-          <a:fillRef idx="3">
-            <a:schemeClr val="accent1"/>
-          </a:fillRef>
-          <a:effectRef idx="2">
-            <a:schemeClr val="accent1"/>
-          </a:effectRef>
-          <a:fontRef idx="minor">
-            <a:schemeClr val="lt1"/>
-          </a:fontRef>
-        </p:style>
-        <p:txBody>
-          <a:bodyPr rtlCol="0" anchor="ctr" lIns="109728" tIns="109728"/>
-          <a:lstStyle/>
-          <a:p>
-            <a:pPr algn="ctr">
-              <a:defRPr b="1" sz="900">
-                <a:solidFill>
-                  <a:srgbClr val="10B981"/>
-                </a:solidFill>
-              </a:defRPr>
-            </a:pPr>
-            <a:r>
-              <a:t>Sprint 4: TIMETABLE SYNC</a:t>
-            </a:r>
-          </a:p>
-          <a:p>
-            <a:pPr>
-              <a:defRPr sz="750">
-                <a:solidFill>
-                  <a:srgbClr val="0F172A"/>
-                </a:solidFill>
-              </a:defRPr>
-            </a:pPr>
-            <a:r>
-              <a:t>• Skill India Portal roster sync</a:t>
-            </a:r>
-          </a:p>
-          <a:p>
-            <a:pPr>
-              <a:defRPr sz="750">
-                <a:solidFill>
-                  <a:srgbClr val="0F172A"/>
-                </a:solidFill>
-              </a:defRPr>
-            </a:pPr>
-            <a:r>
-              <a:t>• Variance = |Claimed - Real|</a:t>
-            </a:r>
-          </a:p>
-          <a:p>
-            <a:pPr>
-              <a:defRPr sz="750">
-                <a:solidFill>
-                  <a:srgbClr val="0F172A"/>
-                </a:solidFill>
-              </a:defRPr>
-            </a:pPr>
-            <a:r>
-              <a:t>• SHA-256 evidence vault</a:t>
-            </a:r>
-          </a:p>
-        </p:txBody>
-      </p:sp>
+        </p:spPr>
+      </p:pic>
     </p:spTree>
   </p:cSld>
   <p:clrMapOvr>

</xml_diff>

<commit_message>
feat(presentation): redesign Slide 2 Proposed Solution matching reference template and workflow
</commit_message>
<xml_diff>
--- a/presentation/Drishti_Skilling_SIH2024_Presentation.pptx
+++ b/presentation/Drishti_Skilling_SIH2024_Presentation.pptx
@@ -3425,8 +3425,8 @@
         </p:nvSpPr>
         <p:spPr>
           <a:xfrm>
-            <a:off x="365760" y="182880"/>
-            <a:ext cx="1371600" cy="640080"/>
+            <a:off x="365760" y="164592"/>
+            <a:ext cx="1188720" cy="658368"/>
           </a:xfrm>
           <a:prstGeom prst="roundRect">
             <a:avLst/>
@@ -3434,7 +3434,7 @@
           <a:solidFill>
             <a:srgbClr val="FFFFFF"/>
           </a:solidFill>
-          <a:ln w="25400">
+          <a:ln w="22860">
             <a:solidFill>
               <a:srgbClr val="1B365D"/>
             </a:solidFill>
@@ -3480,8 +3480,8 @@
         </p:nvSpPr>
         <p:spPr>
           <a:xfrm>
-            <a:off x="1828800" y="164592"/>
-            <a:ext cx="7315200" cy="685800"/>
+            <a:off x="1645920" y="91440"/>
+            <a:ext cx="7772400" cy="777240"/>
           </a:xfrm>
           <a:prstGeom prst="rect">
             <a:avLst/>
@@ -3495,15 +3495,28 @@
           <a:lstStyle/>
           <a:p>
             <a:pPr algn="ctr">
-              <a:defRPr sz="2800" b="1">
-                <a:solidFill>
-                  <a:srgbClr val="0F172A"/>
-                </a:solidFill>
-                <a:latin typeface="Arial"/>
-              </a:defRPr>
-            </a:pPr>
-            <a:r>
-              <a:t>Drishti-Skilling</a:t>
+              <a:defRPr sz="2600" b="1">
+                <a:solidFill>
+                  <a:srgbClr val="1B365D"/>
+                </a:solidFill>
+                <a:latin typeface="Georgia"/>
+              </a:defRPr>
+            </a:pPr>
+            <a:r>
+              <a:t>DRISHTI-SKILLING</a:t>
+            </a:r>
+          </a:p>
+          <a:p>
+            <a:pPr algn="ctr">
+              <a:defRPr sz="1100" i="1">
+                <a:solidFill>
+                  <a:srgbClr val="475569"/>
+                </a:solidFill>
+                <a:latin typeface="Georgia"/>
+              </a:defRPr>
+            </a:pPr>
+            <a:r>
+              <a:t>Privacy-Preserving Edge AI Governance for Vocational Centres</a:t>
             </a:r>
           </a:p>
         </p:txBody>
@@ -3540,8 +3553,8 @@
         </p:nvSpPr>
         <p:spPr>
           <a:xfrm>
-            <a:off x="11155680" y="6217920"/>
-            <a:ext cx="731520" cy="457200"/>
+            <a:off x="11338560" y="6309360"/>
+            <a:ext cx="640080" cy="365760"/>
           </a:xfrm>
           <a:prstGeom prst="rect">
             <a:avLst/>
@@ -3555,7 +3568,7 @@
           <a:lstStyle/>
           <a:p>
             <a:pPr algn="r">
-              <a:defRPr sz="2400" b="1">
+              <a:defRPr sz="1600" b="1">
                 <a:solidFill>
                   <a:srgbClr val="007E8A"/>
                 </a:solidFill>
@@ -3576,8 +3589,63 @@
         </p:nvSpPr>
         <p:spPr>
           <a:xfrm>
-            <a:off x="365760" y="1005840"/>
-            <a:ext cx="5852160" cy="5303520"/>
+            <a:off x="365760" y="960120"/>
+            <a:ext cx="4800600" cy="420624"/>
+          </a:xfrm>
+          <a:prstGeom prst="roundRect">
+            <a:avLst/>
+          </a:prstGeom>
+          <a:solidFill>
+            <a:srgbClr val="0B69A3"/>
+          </a:solidFill>
+          <a:ln w="15240">
+            <a:solidFill>
+              <a:srgbClr val="1B365D"/>
+            </a:solidFill>
+          </a:ln>
+        </p:spPr>
+        <p:style>
+          <a:lnRef idx="1">
+            <a:schemeClr val="accent1"/>
+          </a:lnRef>
+          <a:fillRef idx="3">
+            <a:schemeClr val="accent1"/>
+          </a:fillRef>
+          <a:effectRef idx="2">
+            <a:schemeClr val="accent1"/>
+          </a:effectRef>
+          <a:fontRef idx="minor">
+            <a:schemeClr val="lt1"/>
+          </a:fontRef>
+        </p:style>
+        <p:txBody>
+          <a:bodyPr rtlCol="0" anchor="ctr" lIns="137160"/>
+          <a:lstStyle/>
+          <a:p>
+            <a:pPr algn="ctr">
+              <a:defRPr sz="1400" b="1">
+                <a:solidFill>
+                  <a:srgbClr val="FFFFFF"/>
+                </a:solidFill>
+                <a:latin typeface="Georgia"/>
+              </a:defRPr>
+            </a:pPr>
+            <a:r>
+              <a:t>💡  Proposed Solution / Approach</a:t>
+            </a:r>
+          </a:p>
+        </p:txBody>
+      </p:sp>
+      <p:sp>
+        <p:nvSpPr>
+          <p:cNvPr id="7" name="Rounded Rectangle 6"/>
+          <p:cNvSpPr/>
+          <p:nvPr/>
+        </p:nvSpPr>
+        <p:spPr>
+          <a:xfrm>
+            <a:off x="365760" y="1426464"/>
+            <a:ext cx="4800600" cy="4974336"/>
           </a:xfrm>
           <a:prstGeom prst="roundRect">
             <a:avLst/>
@@ -3585,9 +3653,9 @@
           <a:solidFill>
             <a:srgbClr val="FFFFFF"/>
           </a:solidFill>
-          <a:ln w="19050">
+          <a:ln w="15240">
             <a:solidFill>
-              <a:srgbClr val="007E8A"/>
+              <a:srgbClr val="CBD5E1"/>
             </a:solidFill>
           </a:ln>
         </p:spPr>
@@ -3606,19 +3674,27 @@
           </a:fontRef>
         </p:style>
         <p:txBody>
-          <a:bodyPr rtlCol="0" anchor="ctr" wrap="square" lIns="228600" rIns="228600" tIns="182880"/>
-          <a:lstStyle/>
-          <a:p>
-            <a:pPr algn="ctr">
-              <a:defRPr sz="1400" b="1">
-                <a:solidFill>
-                  <a:srgbClr val="007E8A"/>
+          <a:bodyPr rtlCol="0" anchor="ctr" wrap="square" lIns="182880" rIns="182880" tIns="164592" bIns="137160"/>
+          <a:lstStyle/>
+          <a:p>
+            <a:pPr algn="ctr"/>
+            <a:r>
+              <a:rPr sz="980" b="1">
+                <a:solidFill>
+                  <a:srgbClr val="0F172A"/>
                 </a:solidFill>
                 <a:latin typeface="Arial"/>
-              </a:defRPr>
-            </a:pPr>
-            <a:r>
-              <a:t>Detailed explanation of the proposed solution</a:t>
+              </a:rPr>
+              <a:t>• Assured Edge Video Analytics: </a:t>
+            </a:r>
+            <a:r>
+              <a:rPr sz="919">
+                <a:solidFill>
+                  <a:srgbClr val="475569"/>
+                </a:solidFill>
+                <a:latin typeface="Arial"/>
+              </a:rPr>
+              <a:t>Eliminates bandwidth bottlenecks by ingesting existing lab RTSP CCTV feeds locally on an affordable on-premise Mini-PC. Processes frames on-device with zero raw cloud video streaming required.</a:t>
             </a:r>
           </a:p>
           <a:p>
@@ -3626,15 +3702,24 @@
               <a:spcBef>
                 <a:spcPts val="600"/>
               </a:spcBef>
-              <a:defRPr sz="980">
+            </a:pPr>
+            <a:r>
+              <a:rPr sz="980" b="1">
                 <a:solidFill>
                   <a:srgbClr val="0F172A"/>
                 </a:solidFill>
                 <a:latin typeface="Arial"/>
-              </a:defRPr>
-            </a:pPr>
-            <a:r>
-              <a:t>Drishti-Skilling is an edge-native, privacy-preserving video analytics platform designed to transform vocational centre monitoring under national schemes (PMKVY, DGT, ITIs). It guarantees authentic trainee attendance and verifies practical lab infrastructure while completely protecting citizen privacy through real-time hardware-accelerated face de-identification.</a:t>
+              </a:rPr>
+              <a:t>• 50 FPS Volatile RAM Face De-ID: </a:t>
+            </a:r>
+            <a:r>
+              <a:rPr sz="919">
+                <a:solidFill>
+                  <a:srgbClr val="475569"/>
+                </a:solidFill>
+                <a:latin typeface="Arial"/>
+              </a:rPr>
+              <a:t>Irreversibly blurs trainee faces directly in volatile RAM via BlazeFace before any processing. Fully compliant with DPDP Act 2023 with zero facial biometric vectors stored or leaked.</a:t>
             </a:r>
           </a:p>
           <a:p>
@@ -3642,22 +3727,106 @@
               <a:spcBef>
                 <a:spcPts val="600"/>
               </a:spcBef>
-              <a:defRPr sz="980">
+            </a:pPr>
+            <a:r>
+              <a:rPr sz="980" b="1">
                 <a:solidFill>
                   <a:srgbClr val="0F172A"/>
                 </a:solidFill>
                 <a:latin typeface="Arial"/>
-              </a:defRPr>
-            </a:pPr>
-            <a:r>
-              <a:t>Key capabilities include High-Frequency 50 FPS Face De-Identification (DPDP Act 2023 compliant), Spatial Headcount &amp; Machinery Detection (YOLOv8), 72-Hour Offline Store-and-Forward Telemetry (syncing ultra-light 2-5 KB JSON packets), and Real-Time Timetable Reconciliation against Skill India Portal rosters. The system delivers automated risk-tiered triage for flying squads and eliminates stipend fraud.</a:t>
+              </a:rPr>
+              <a:t>• Dual-Factor Trainee &amp; Equipment Audit: </a:t>
+            </a:r>
+            <a:r>
+              <a:rPr sz="919">
+                <a:solidFill>
+                  <a:srgbClr val="475569"/>
+                </a:solidFill>
+                <a:latin typeface="Arial"/>
+              </a:rPr>
+              <a:t>YOLOv8 simultaneously verifies physical student presence and audits mandatory trade machines (welding booths, wiring boards, multimeters) to eradicate rented machinery scams.</a:t>
+            </a:r>
+          </a:p>
+          <a:p>
+            <a:pPr>
+              <a:spcBef>
+                <a:spcPts val="600"/>
+              </a:spcBef>
+            </a:pPr>
+            <a:r>
+              <a:rPr sz="980" b="1">
+                <a:solidFill>
+                  <a:srgbClr val="0F172A"/>
+                </a:solidFill>
+                <a:latin typeface="Arial"/>
+              </a:rPr>
+              <a:t>• Temporal Consistency Rolling Filter: </a:t>
+            </a:r>
+            <a:r>
+              <a:rPr sz="919">
+                <a:solidFill>
+                  <a:srgbClr val="475569"/>
+                </a:solidFill>
+                <a:latin typeface="Arial"/>
+              </a:rPr>
+              <a:t>Enforces a 5-minute rolling average window to eliminate false alarms caused by transient student movement, washroom breaks, or water intervals during practical sessions.</a:t>
+            </a:r>
+          </a:p>
+          <a:p>
+            <a:pPr>
+              <a:spcBef>
+                <a:spcPts val="600"/>
+              </a:spcBef>
+            </a:pPr>
+            <a:r>
+              <a:rPr sz="980" b="1">
+                <a:solidFill>
+                  <a:srgbClr val="0F172A"/>
+                </a:solidFill>
+                <a:latin typeface="Arial"/>
+              </a:rPr>
+              <a:t>• Automated Timetable Cross-Reconciliation: </a:t>
+            </a:r>
+            <a:r>
+              <a:rPr sz="919">
+                <a:solidFill>
+                  <a:srgbClr val="475569"/>
+                </a:solidFill>
+                <a:latin typeface="Arial"/>
+              </a:rPr>
+              <a:t>Cross-matches edge telemetry against Skill India Portal (SIDH) rosters in real-time, automatically flagging ghost enrollments and locking DBT subsidy grants on deficit.</a:t>
+            </a:r>
+          </a:p>
+          <a:p>
+            <a:pPr>
+              <a:spcBef>
+                <a:spcPts val="800"/>
+              </a:spcBef>
+            </a:pPr>
+            <a:r>
+              <a:rPr sz="900" b="1">
+                <a:solidFill>
+                  <a:srgbClr val="0284C7"/>
+                </a:solidFill>
+                <a:latin typeface="Arial"/>
+              </a:rPr>
+              <a:t>🔗 Live Production Demo: </a:t>
+            </a:r>
+            <a:r>
+              <a:rPr sz="900" b="1" u="sng">
+                <a:solidFill>
+                  <a:srgbClr val="0284C7"/>
+                </a:solidFill>
+                <a:latin typeface="Arial"/>
+              </a:rPr>
+              <a:t>https://drishti-skilling.vercel.app/</a:t>
             </a:r>
           </a:p>
         </p:txBody>
       </p:sp>
       <p:pic>
         <p:nvPicPr>
-          <p:cNvPr id="7" name="Picture 6" descr="slide2_orbital.png"/>
+          <p:cNvPr id="8" name="Picture 7" descr="slide2_workflow_e2e.png"/>
           <p:cNvPicPr>
             <a:picLocks noChangeAspect="1"/>
           </p:cNvPicPr>
@@ -3671,53 +3840,17 @@
         </p:blipFill>
         <p:spPr>
           <a:xfrm>
-            <a:off x="502920" y="4736592"/>
-            <a:ext cx="5577840" cy="1065430"/>
+            <a:off x="5321808" y="960120"/>
+            <a:ext cx="6537960" cy="3080385"/>
           </a:xfrm>
           <a:prstGeom prst="rect">
             <a:avLst/>
           </a:prstGeom>
         </p:spPr>
       </p:pic>
-      <p:sp>
-        <p:nvSpPr>
-          <p:cNvPr id="8" name="TextBox 7"/>
-          <p:cNvSpPr txBox="1"/>
-          <p:nvPr/>
-        </p:nvSpPr>
-        <p:spPr>
-          <a:xfrm>
-            <a:off x="6492240" y="960120"/>
-            <a:ext cx="5303520" cy="320040"/>
-          </a:xfrm>
-          <a:prstGeom prst="rect">
-            <a:avLst/>
-          </a:prstGeom>
-          <a:noFill/>
-        </p:spPr>
-        <p:txBody>
-          <a:bodyPr wrap="none" lIns="0" tIns="0">
-            <a:spAutoFit/>
-          </a:bodyPr>
-          <a:lstStyle/>
-          <a:p>
-            <a:pPr>
-              <a:defRPr sz="1300" b="1">
-                <a:solidFill>
-                  <a:srgbClr val="007E8A"/>
-                </a:solidFill>
-                <a:latin typeface="Arial"/>
-              </a:defRPr>
-            </a:pPr>
-            <a:r>
-              <a:t>How it addresses the problem</a:t>
-            </a:r>
-          </a:p>
-        </p:txBody>
-      </p:sp>
       <p:pic>
         <p:nvPicPr>
-          <p:cNvPr id="9" name="Picture 8" descr="slide2_workflow.png"/>
+          <p:cNvPr id="9" name="Picture 8" descr="slide2_innovation_cards.png"/>
           <p:cNvPicPr>
             <a:picLocks noChangeAspect="1"/>
           </p:cNvPicPr>
@@ -3731,110 +3864,14 @@
         </p:blipFill>
         <p:spPr>
           <a:xfrm>
-            <a:off x="6492240" y="1298448"/>
-            <a:ext cx="5303520" cy="2083526"/>
+            <a:off x="5321808" y="4096512"/>
+            <a:ext cx="6537960" cy="2703195"/>
           </a:xfrm>
           <a:prstGeom prst="rect">
             <a:avLst/>
           </a:prstGeom>
         </p:spPr>
       </p:pic>
-      <p:sp>
-        <p:nvSpPr>
-          <p:cNvPr id="10" name="TextBox 9"/>
-          <p:cNvSpPr txBox="1"/>
-          <p:nvPr/>
-        </p:nvSpPr>
-        <p:spPr>
-          <a:xfrm>
-            <a:off x="6492240" y="3547872"/>
-            <a:ext cx="5303520" cy="320040"/>
-          </a:xfrm>
-          <a:prstGeom prst="rect">
-            <a:avLst/>
-          </a:prstGeom>
-          <a:noFill/>
-        </p:spPr>
-        <p:txBody>
-          <a:bodyPr wrap="none" lIns="0" tIns="0">
-            <a:spAutoFit/>
-          </a:bodyPr>
-          <a:lstStyle/>
-          <a:p>
-            <a:pPr>
-              <a:defRPr sz="1300" b="1">
-                <a:solidFill>
-                  <a:srgbClr val="007E8A"/>
-                </a:solidFill>
-                <a:latin typeface="Arial"/>
-              </a:defRPr>
-            </a:pPr>
-            <a:r>
-              <a:t>Innovation and uniqueness of the solution</a:t>
-            </a:r>
-          </a:p>
-        </p:txBody>
-      </p:sp>
-      <p:pic>
-        <p:nvPicPr>
-          <p:cNvPr id="11" name="Picture 10" descr="slide2_innovations.png"/>
-          <p:cNvPicPr>
-            <a:picLocks noChangeAspect="1"/>
-          </p:cNvPicPr>
-          <p:nvPr/>
-        </p:nvPicPr>
-        <p:blipFill>
-          <a:blip r:embed="rId5"/>
-          <a:stretch>
-            <a:fillRect/>
-          </a:stretch>
-        </p:blipFill>
-        <p:spPr>
-          <a:xfrm>
-            <a:off x="6492240" y="3886200"/>
-            <a:ext cx="5303520" cy="2083526"/>
-          </a:xfrm>
-          <a:prstGeom prst="rect">
-            <a:avLst/>
-          </a:prstGeom>
-        </p:spPr>
-      </p:pic>
-      <p:sp>
-        <p:nvSpPr>
-          <p:cNvPr id="12" name="TextBox 11"/>
-          <p:cNvSpPr txBox="1"/>
-          <p:nvPr/>
-        </p:nvSpPr>
-        <p:spPr>
-          <a:xfrm>
-            <a:off x="6492240" y="6172200"/>
-            <a:ext cx="4572000" cy="320040"/>
-          </a:xfrm>
-          <a:prstGeom prst="rect">
-            <a:avLst/>
-          </a:prstGeom>
-          <a:noFill/>
-        </p:spPr>
-        <p:txBody>
-          <a:bodyPr wrap="none" lIns="0" tIns="0">
-            <a:spAutoFit/>
-          </a:bodyPr>
-          <a:lstStyle/>
-          <a:p>
-            <a:pPr algn="l">
-              <a:defRPr sz="950" b="1">
-                <a:solidFill>
-                  <a:srgbClr val="0284C7"/>
-                </a:solidFill>
-                <a:latin typeface="Arial"/>
-              </a:defRPr>
-            </a:pPr>
-            <a:r>
-              <a:t>Live Production Demo: https://drishti-skilling.vercel.app/</a:t>
-            </a:r>
-          </a:p>
-        </p:txBody>
-      </p:sp>
     </p:spTree>
   </p:cSld>
   <p:clrMapOvr>
@@ -3861,8 +3898,8 @@
         </p:nvSpPr>
         <p:spPr>
           <a:xfrm>
-            <a:off x="365760" y="182880"/>
-            <a:ext cx="1371600" cy="640080"/>
+            <a:off x="365760" y="164592"/>
+            <a:ext cx="1188720" cy="658368"/>
           </a:xfrm>
           <a:prstGeom prst="roundRect">
             <a:avLst/>
@@ -3870,7 +3907,7 @@
           <a:solidFill>
             <a:srgbClr val="FFFFFF"/>
           </a:solidFill>
-          <a:ln w="25400">
+          <a:ln w="22860">
             <a:solidFill>
               <a:srgbClr val="1B365D"/>
             </a:solidFill>
@@ -3916,8 +3953,8 @@
         </p:nvSpPr>
         <p:spPr>
           <a:xfrm>
-            <a:off x="1828800" y="164592"/>
-            <a:ext cx="7315200" cy="685800"/>
+            <a:off x="1645920" y="91440"/>
+            <a:ext cx="7772400" cy="777240"/>
           </a:xfrm>
           <a:prstGeom prst="rect">
             <a:avLst/>
@@ -3931,11 +3968,11 @@
           <a:lstStyle/>
           <a:p>
             <a:pPr algn="ctr">
-              <a:defRPr sz="2800" b="1">
-                <a:solidFill>
-                  <a:srgbClr val="0F172A"/>
-                </a:solidFill>
-                <a:latin typeface="Arial"/>
+              <a:defRPr sz="2600" b="1">
+                <a:solidFill>
+                  <a:srgbClr val="1B365D"/>
+                </a:solidFill>
+                <a:latin typeface="Georgia"/>
               </a:defRPr>
             </a:pPr>
             <a:r>
@@ -3976,8 +4013,8 @@
         </p:nvSpPr>
         <p:spPr>
           <a:xfrm>
-            <a:off x="11155680" y="6217920"/>
-            <a:ext cx="731520" cy="457200"/>
+            <a:off x="11338560" y="6309360"/>
+            <a:ext cx="640080" cy="365760"/>
           </a:xfrm>
           <a:prstGeom prst="rect">
             <a:avLst/>
@@ -3991,7 +4028,7 @@
           <a:lstStyle/>
           <a:p>
             <a:pPr algn="r">
-              <a:defRPr sz="2400" b="1">
+              <a:defRPr sz="1600" b="1">
                 <a:solidFill>
                   <a:srgbClr val="007E8A"/>
                 </a:solidFill>
@@ -4570,8 +4607,8 @@
         </p:nvSpPr>
         <p:spPr>
           <a:xfrm>
-            <a:off x="365760" y="182880"/>
-            <a:ext cx="1371600" cy="640080"/>
+            <a:off x="365760" y="164592"/>
+            <a:ext cx="1188720" cy="658368"/>
           </a:xfrm>
           <a:prstGeom prst="roundRect">
             <a:avLst/>
@@ -4579,7 +4616,7 @@
           <a:solidFill>
             <a:srgbClr val="FFFFFF"/>
           </a:solidFill>
-          <a:ln w="25400">
+          <a:ln w="22860">
             <a:solidFill>
               <a:srgbClr val="1B365D"/>
             </a:solidFill>
@@ -4625,8 +4662,8 @@
         </p:nvSpPr>
         <p:spPr>
           <a:xfrm>
-            <a:off x="1828800" y="164592"/>
-            <a:ext cx="7315200" cy="685800"/>
+            <a:off x="1645920" y="91440"/>
+            <a:ext cx="7772400" cy="777240"/>
           </a:xfrm>
           <a:prstGeom prst="rect">
             <a:avLst/>
@@ -4640,11 +4677,11 @@
           <a:lstStyle/>
           <a:p>
             <a:pPr algn="ctr">
-              <a:defRPr sz="2800" b="1">
-                <a:solidFill>
-                  <a:srgbClr val="0F172A"/>
-                </a:solidFill>
-                <a:latin typeface="Arial"/>
+              <a:defRPr sz="2600" b="1">
+                <a:solidFill>
+                  <a:srgbClr val="1B365D"/>
+                </a:solidFill>
+                <a:latin typeface="Georgia"/>
               </a:defRPr>
             </a:pPr>
             <a:r>
@@ -4685,8 +4722,8 @@
         </p:nvSpPr>
         <p:spPr>
           <a:xfrm>
-            <a:off x="11155680" y="6217920"/>
-            <a:ext cx="731520" cy="457200"/>
+            <a:off x="11338560" y="6309360"/>
+            <a:ext cx="640080" cy="365760"/>
           </a:xfrm>
           <a:prstGeom prst="rect">
             <a:avLst/>
@@ -4700,7 +4737,7 @@
           <a:lstStyle/>
           <a:p>
             <a:pPr algn="r">
-              <a:defRPr sz="2400" b="1">
+              <a:defRPr sz="1600" b="1">
                 <a:solidFill>
                   <a:srgbClr val="007E8A"/>
                 </a:solidFill>
@@ -5206,8 +5243,8 @@
         </p:nvSpPr>
         <p:spPr>
           <a:xfrm>
-            <a:off x="365760" y="182880"/>
-            <a:ext cx="1371600" cy="640080"/>
+            <a:off x="365760" y="164592"/>
+            <a:ext cx="1188720" cy="658368"/>
           </a:xfrm>
           <a:prstGeom prst="roundRect">
             <a:avLst/>
@@ -5215,7 +5252,7 @@
           <a:solidFill>
             <a:srgbClr val="FFFFFF"/>
           </a:solidFill>
-          <a:ln w="25400">
+          <a:ln w="22860">
             <a:solidFill>
               <a:srgbClr val="1B365D"/>
             </a:solidFill>
@@ -5261,8 +5298,8 @@
         </p:nvSpPr>
         <p:spPr>
           <a:xfrm>
-            <a:off x="1828800" y="164592"/>
-            <a:ext cx="7315200" cy="685800"/>
+            <a:off x="1645920" y="91440"/>
+            <a:ext cx="7772400" cy="777240"/>
           </a:xfrm>
           <a:prstGeom prst="rect">
             <a:avLst/>
@@ -5276,11 +5313,11 @@
           <a:lstStyle/>
           <a:p>
             <a:pPr algn="ctr">
-              <a:defRPr sz="2800" b="1">
-                <a:solidFill>
-                  <a:srgbClr val="0F172A"/>
-                </a:solidFill>
-                <a:latin typeface="Arial"/>
+              <a:defRPr sz="2600" b="1">
+                <a:solidFill>
+                  <a:srgbClr val="1B365D"/>
+                </a:solidFill>
+                <a:latin typeface="Georgia"/>
               </a:defRPr>
             </a:pPr>
             <a:r>
@@ -5321,8 +5358,8 @@
         </p:nvSpPr>
         <p:spPr>
           <a:xfrm>
-            <a:off x="11155680" y="6217920"/>
-            <a:ext cx="731520" cy="457200"/>
+            <a:off x="11338560" y="6309360"/>
+            <a:ext cx="640080" cy="365760"/>
           </a:xfrm>
           <a:prstGeom prst="rect">
             <a:avLst/>
@@ -5336,7 +5373,7 @@
           <a:lstStyle/>
           <a:p>
             <a:pPr algn="r">
-              <a:defRPr sz="2400" b="1">
+              <a:defRPr sz="1600" b="1">
                 <a:solidFill>
                   <a:srgbClr val="007E8A"/>
                 </a:solidFill>
@@ -6177,8 +6214,8 @@
         </p:nvSpPr>
         <p:spPr>
           <a:xfrm>
-            <a:off x="365760" y="182880"/>
-            <a:ext cx="1371600" cy="640080"/>
+            <a:off x="365760" y="164592"/>
+            <a:ext cx="1188720" cy="658368"/>
           </a:xfrm>
           <a:prstGeom prst="roundRect">
             <a:avLst/>
@@ -6186,7 +6223,7 @@
           <a:solidFill>
             <a:srgbClr val="FFFFFF"/>
           </a:solidFill>
-          <a:ln w="25400">
+          <a:ln w="22860">
             <a:solidFill>
               <a:srgbClr val="1B365D"/>
             </a:solidFill>
@@ -6232,8 +6269,8 @@
         </p:nvSpPr>
         <p:spPr>
           <a:xfrm>
-            <a:off x="1828800" y="164592"/>
-            <a:ext cx="7315200" cy="685800"/>
+            <a:off x="1645920" y="91440"/>
+            <a:ext cx="7772400" cy="777240"/>
           </a:xfrm>
           <a:prstGeom prst="rect">
             <a:avLst/>
@@ -6247,11 +6284,11 @@
           <a:lstStyle/>
           <a:p>
             <a:pPr algn="ctr">
-              <a:defRPr sz="2800" b="1">
-                <a:solidFill>
-                  <a:srgbClr val="0F172A"/>
-                </a:solidFill>
-                <a:latin typeface="Arial"/>
+              <a:defRPr sz="2600" b="1">
+                <a:solidFill>
+                  <a:srgbClr val="1B365D"/>
+                </a:solidFill>
+                <a:latin typeface="Georgia"/>
               </a:defRPr>
             </a:pPr>
             <a:r>
@@ -6292,8 +6329,8 @@
         </p:nvSpPr>
         <p:spPr>
           <a:xfrm>
-            <a:off x="11155680" y="6217920"/>
-            <a:ext cx="731520" cy="457200"/>
+            <a:off x="11338560" y="6309360"/>
+            <a:ext cx="640080" cy="365760"/>
           </a:xfrm>
           <a:prstGeom prst="rect">
             <a:avLst/>
@@ -6307,7 +6344,7 @@
           <a:lstStyle/>
           <a:p>
             <a:pPr algn="r">
-              <a:defRPr sz="2400" b="1">
+              <a:defRPr sz="1600" b="1">
                 <a:solidFill>
                   <a:srgbClr val="007E8A"/>
                 </a:solidFill>

</xml_diff>

<commit_message>
feat(presentation): embed 3-in-1 proposed solution visual on slide 2 with zero empty space
</commit_message>
<xml_diff>
--- a/presentation/Drishti_Skilling_SIH2024_Presentation.pptx
+++ b/presentation/Drishti_Skilling_SIH2024_Presentation.pptx
@@ -3545,288 +3545,9 @@
           </a:prstGeom>
         </p:spPr>
       </p:pic>
-      <p:sp>
-        <p:nvSpPr>
-          <p:cNvPr id="5" name="TextBox 4"/>
-          <p:cNvSpPr txBox="1"/>
-          <p:nvPr/>
-        </p:nvSpPr>
-        <p:spPr>
-          <a:xfrm>
-            <a:off x="11338560" y="6309360"/>
-            <a:ext cx="640080" cy="365760"/>
-          </a:xfrm>
-          <a:prstGeom prst="rect">
-            <a:avLst/>
-          </a:prstGeom>
-          <a:noFill/>
-        </p:spPr>
-        <p:txBody>
-          <a:bodyPr wrap="none">
-            <a:spAutoFit/>
-          </a:bodyPr>
-          <a:lstStyle/>
-          <a:p>
-            <a:pPr algn="r">
-              <a:defRPr sz="1600" b="1">
-                <a:solidFill>
-                  <a:srgbClr val="007E8A"/>
-                </a:solidFill>
-                <a:latin typeface="Arial"/>
-              </a:defRPr>
-            </a:pPr>
-            <a:r>
-              <a:t>2</a:t>
-            </a:r>
-          </a:p>
-        </p:txBody>
-      </p:sp>
-      <p:sp>
-        <p:nvSpPr>
-          <p:cNvPr id="6" name="Rounded Rectangle 5"/>
-          <p:cNvSpPr/>
-          <p:nvPr/>
-        </p:nvSpPr>
-        <p:spPr>
-          <a:xfrm>
-            <a:off x="365760" y="960120"/>
-            <a:ext cx="4800600" cy="420624"/>
-          </a:xfrm>
-          <a:prstGeom prst="roundRect">
-            <a:avLst/>
-          </a:prstGeom>
-          <a:solidFill>
-            <a:srgbClr val="0B69A3"/>
-          </a:solidFill>
-          <a:ln w="15240">
-            <a:solidFill>
-              <a:srgbClr val="1B365D"/>
-            </a:solidFill>
-          </a:ln>
-        </p:spPr>
-        <p:style>
-          <a:lnRef idx="1">
-            <a:schemeClr val="accent1"/>
-          </a:lnRef>
-          <a:fillRef idx="3">
-            <a:schemeClr val="accent1"/>
-          </a:fillRef>
-          <a:effectRef idx="2">
-            <a:schemeClr val="accent1"/>
-          </a:effectRef>
-          <a:fontRef idx="minor">
-            <a:schemeClr val="lt1"/>
-          </a:fontRef>
-        </p:style>
-        <p:txBody>
-          <a:bodyPr rtlCol="0" anchor="ctr" lIns="137160"/>
-          <a:lstStyle/>
-          <a:p>
-            <a:pPr algn="ctr">
-              <a:defRPr sz="1400" b="1">
-                <a:solidFill>
-                  <a:srgbClr val="FFFFFF"/>
-                </a:solidFill>
-                <a:latin typeface="Georgia"/>
-              </a:defRPr>
-            </a:pPr>
-            <a:r>
-              <a:t>💡  Proposed Solution / Approach</a:t>
-            </a:r>
-          </a:p>
-        </p:txBody>
-      </p:sp>
-      <p:sp>
-        <p:nvSpPr>
-          <p:cNvPr id="7" name="Rounded Rectangle 6"/>
-          <p:cNvSpPr/>
-          <p:nvPr/>
-        </p:nvSpPr>
-        <p:spPr>
-          <a:xfrm>
-            <a:off x="365760" y="1426464"/>
-            <a:ext cx="4800600" cy="4974336"/>
-          </a:xfrm>
-          <a:prstGeom prst="roundRect">
-            <a:avLst/>
-          </a:prstGeom>
-          <a:solidFill>
-            <a:srgbClr val="FFFFFF"/>
-          </a:solidFill>
-          <a:ln w="15240">
-            <a:solidFill>
-              <a:srgbClr val="CBD5E1"/>
-            </a:solidFill>
-          </a:ln>
-        </p:spPr>
-        <p:style>
-          <a:lnRef idx="1">
-            <a:schemeClr val="accent1"/>
-          </a:lnRef>
-          <a:fillRef idx="3">
-            <a:schemeClr val="accent1"/>
-          </a:fillRef>
-          <a:effectRef idx="2">
-            <a:schemeClr val="accent1"/>
-          </a:effectRef>
-          <a:fontRef idx="minor">
-            <a:schemeClr val="lt1"/>
-          </a:fontRef>
-        </p:style>
-        <p:txBody>
-          <a:bodyPr rtlCol="0" anchor="ctr" wrap="square" lIns="182880" rIns="182880" tIns="164592" bIns="137160"/>
-          <a:lstStyle/>
-          <a:p>
-            <a:pPr algn="ctr"/>
-            <a:r>
-              <a:rPr sz="980" b="1">
-                <a:solidFill>
-                  <a:srgbClr val="0F172A"/>
-                </a:solidFill>
-                <a:latin typeface="Arial"/>
-              </a:rPr>
-              <a:t>• Assured Edge Video Analytics: </a:t>
-            </a:r>
-            <a:r>
-              <a:rPr sz="919">
-                <a:solidFill>
-                  <a:srgbClr val="475569"/>
-                </a:solidFill>
-                <a:latin typeface="Arial"/>
-              </a:rPr>
-              <a:t>Eliminates bandwidth bottlenecks by ingesting existing lab RTSP CCTV feeds locally on an affordable on-premise Mini-PC. Processes frames on-device with zero raw cloud video streaming required.</a:t>
-            </a:r>
-          </a:p>
-          <a:p>
-            <a:pPr>
-              <a:spcBef>
-                <a:spcPts val="600"/>
-              </a:spcBef>
-            </a:pPr>
-            <a:r>
-              <a:rPr sz="980" b="1">
-                <a:solidFill>
-                  <a:srgbClr val="0F172A"/>
-                </a:solidFill>
-                <a:latin typeface="Arial"/>
-              </a:rPr>
-              <a:t>• 50 FPS Volatile RAM Face De-ID: </a:t>
-            </a:r>
-            <a:r>
-              <a:rPr sz="919">
-                <a:solidFill>
-                  <a:srgbClr val="475569"/>
-                </a:solidFill>
-                <a:latin typeface="Arial"/>
-              </a:rPr>
-              <a:t>Irreversibly blurs trainee faces directly in volatile RAM via BlazeFace before any processing. Fully compliant with DPDP Act 2023 with zero facial biometric vectors stored or leaked.</a:t>
-            </a:r>
-          </a:p>
-          <a:p>
-            <a:pPr>
-              <a:spcBef>
-                <a:spcPts val="600"/>
-              </a:spcBef>
-            </a:pPr>
-            <a:r>
-              <a:rPr sz="980" b="1">
-                <a:solidFill>
-                  <a:srgbClr val="0F172A"/>
-                </a:solidFill>
-                <a:latin typeface="Arial"/>
-              </a:rPr>
-              <a:t>• Dual-Factor Trainee &amp; Equipment Audit: </a:t>
-            </a:r>
-            <a:r>
-              <a:rPr sz="919">
-                <a:solidFill>
-                  <a:srgbClr val="475569"/>
-                </a:solidFill>
-                <a:latin typeface="Arial"/>
-              </a:rPr>
-              <a:t>YOLOv8 simultaneously verifies physical student presence and audits mandatory trade machines (welding booths, wiring boards, multimeters) to eradicate rented machinery scams.</a:t>
-            </a:r>
-          </a:p>
-          <a:p>
-            <a:pPr>
-              <a:spcBef>
-                <a:spcPts val="600"/>
-              </a:spcBef>
-            </a:pPr>
-            <a:r>
-              <a:rPr sz="980" b="1">
-                <a:solidFill>
-                  <a:srgbClr val="0F172A"/>
-                </a:solidFill>
-                <a:latin typeface="Arial"/>
-              </a:rPr>
-              <a:t>• Temporal Consistency Rolling Filter: </a:t>
-            </a:r>
-            <a:r>
-              <a:rPr sz="919">
-                <a:solidFill>
-                  <a:srgbClr val="475569"/>
-                </a:solidFill>
-                <a:latin typeface="Arial"/>
-              </a:rPr>
-              <a:t>Enforces a 5-minute rolling average window to eliminate false alarms caused by transient student movement, washroom breaks, or water intervals during practical sessions.</a:t>
-            </a:r>
-          </a:p>
-          <a:p>
-            <a:pPr>
-              <a:spcBef>
-                <a:spcPts val="600"/>
-              </a:spcBef>
-            </a:pPr>
-            <a:r>
-              <a:rPr sz="980" b="1">
-                <a:solidFill>
-                  <a:srgbClr val="0F172A"/>
-                </a:solidFill>
-                <a:latin typeface="Arial"/>
-              </a:rPr>
-              <a:t>• Automated Timetable Cross-Reconciliation: </a:t>
-            </a:r>
-            <a:r>
-              <a:rPr sz="919">
-                <a:solidFill>
-                  <a:srgbClr val="475569"/>
-                </a:solidFill>
-                <a:latin typeface="Arial"/>
-              </a:rPr>
-              <a:t>Cross-matches edge telemetry against Skill India Portal (SIDH) rosters in real-time, automatically flagging ghost enrollments and locking DBT subsidy grants on deficit.</a:t>
-            </a:r>
-          </a:p>
-          <a:p>
-            <a:pPr>
-              <a:spcBef>
-                <a:spcPts val="800"/>
-              </a:spcBef>
-            </a:pPr>
-            <a:r>
-              <a:rPr sz="900" b="1">
-                <a:solidFill>
-                  <a:srgbClr val="0284C7"/>
-                </a:solidFill>
-                <a:latin typeface="Arial"/>
-              </a:rPr>
-              <a:t>🔗 Live Production Demo: </a:t>
-            </a:r>
-            <a:r>
-              <a:rPr sz="900" b="1" u="sng">
-                <a:solidFill>
-                  <a:srgbClr val="0284C7"/>
-                </a:solidFill>
-                <a:latin typeface="Arial"/>
-              </a:rPr>
-              <a:t>https://drishti-skilling.vercel.app/</a:t>
-            </a:r>
-          </a:p>
-        </p:txBody>
-      </p:sp>
       <p:pic>
         <p:nvPicPr>
-          <p:cNvPr id="8" name="Picture 7" descr="slide2_workflow_e2e.png"/>
+          <p:cNvPr id="5" name="Picture 4" descr="slide2_proposed_solution_complete.png"/>
           <p:cNvPicPr>
             <a:picLocks noChangeAspect="1"/>
           </p:cNvPicPr>
@@ -3840,38 +3561,50 @@
         </p:blipFill>
         <p:spPr>
           <a:xfrm>
-            <a:off x="5321808" y="960120"/>
-            <a:ext cx="6537960" cy="3080385"/>
+            <a:off x="320040" y="932688"/>
+            <a:ext cx="11548872" cy="5779008"/>
           </a:xfrm>
           <a:prstGeom prst="rect">
             <a:avLst/>
           </a:prstGeom>
         </p:spPr>
       </p:pic>
-      <p:pic>
-        <p:nvPicPr>
-          <p:cNvPr id="9" name="Picture 8" descr="slide2_innovation_cards.png"/>
-          <p:cNvPicPr>
-            <a:picLocks noChangeAspect="1"/>
-          </p:cNvPicPr>
+      <p:sp>
+        <p:nvSpPr>
+          <p:cNvPr id="6" name="TextBox 5"/>
+          <p:cNvSpPr txBox="1"/>
           <p:nvPr/>
-        </p:nvPicPr>
-        <p:blipFill>
-          <a:blip r:embed="rId4"/>
-          <a:stretch>
-            <a:fillRect/>
-          </a:stretch>
-        </p:blipFill>
-        <p:spPr>
-          <a:xfrm>
-            <a:off x="5321808" y="4096512"/>
-            <a:ext cx="6537960" cy="2703195"/>
+        </p:nvSpPr>
+        <p:spPr>
+          <a:xfrm>
+            <a:off x="11338560" y="6327648"/>
+            <a:ext cx="640080" cy="365760"/>
           </a:xfrm>
           <a:prstGeom prst="rect">
             <a:avLst/>
           </a:prstGeom>
-        </p:spPr>
-      </p:pic>
+          <a:noFill/>
+        </p:spPr>
+        <p:txBody>
+          <a:bodyPr wrap="none">
+            <a:spAutoFit/>
+          </a:bodyPr>
+          <a:lstStyle/>
+          <a:p>
+            <a:pPr algn="r">
+              <a:defRPr sz="1600" b="1">
+                <a:solidFill>
+                  <a:srgbClr val="007E8A"/>
+                </a:solidFill>
+                <a:latin typeface="Arial"/>
+              </a:defRPr>
+            </a:pPr>
+            <a:r>
+              <a:t>2</a:t>
+            </a:r>
+          </a:p>
+        </p:txBody>
+      </p:sp>
     </p:spTree>
   </p:cSld>
   <p:clrMapOvr>

</xml_diff>